<commit_message>
Refine noether braid taxonomy proof map
</commit_message>
<xml_diff>
--- a/reference/archie/presentations/NPQG Fundamentals - Energy.pptx
+++ b/reference/archie/presentations/NPQG Fundamentals - Energy.pptx
@@ -3824,7 +3824,7 @@
 </file>
 
 <file path=ppt/slides/slide1.xml><?xml version="1.0" encoding="utf-8"?>
-<p:sld xmlns:a="http://schemas.openxmlformats.org/drawingml/2006/main" xmlns:a16="http://schemas.microsoft.com/office/drawing/2014/main" xmlns:ns2="http://schemas.openxmlformats.org/markup-compatibility/2006" xmlns:ns4="http://schemas.microsoft.com/office/drawing/2010/main" xmlns:ns5="http://schemas.openxmlformats.org/officeDocument/2006/math" xmlns:ns7="http://schemas.microsoft.com/office/powerpoint/2010/main" xmlns:p="http://schemas.openxmlformats.org/presentationml/2006/main" xmlns:r="http://schemas.openxmlformats.org/officeDocument/2006/relationships">
+<p:sld xmlns:a="http://schemas.openxmlformats.org/drawingml/2006/main" xmlns:a14="http://schemas.microsoft.com/office/drawing/2010/main" xmlns:a16="http://schemas.microsoft.com/office/drawing/2014/main" xmlns:m="http://schemas.openxmlformats.org/officeDocument/2006/math" xmlns:ns2="http://schemas.openxmlformats.org/markup-compatibility/2006" xmlns:ns6="http://schemas.microsoft.com/office/powerpoint/2010/main" xmlns:p="http://schemas.openxmlformats.org/presentationml/2006/main">
   <p:cSld>
     <p:bg>
       <p:bgPr>
@@ -3895,11 +3895,11 @@
                   <a:tabLst/>
                   <a:defRPr/>
                 </a:pPr>
-                <ns4:m>
-                  <ns5:oMath>
-                    <ns5:sSub>
-                      <ns5:sSubPr>
-                        <ns5:ctrlPr>
+                <a14:m>
+                  <m:oMath>
+                    <m:sSub>
+                      <m:sSubPr>
+                        <m:ctrlPr>
                           <a:rPr kumimoji="0" lang="en-US" sz="1800" b="0" i="1" u="none" strike="noStrike" kern="1200" cap="none" spc="0" normalizeH="0" baseline="0" noProof="0" smtClean="0">
                             <a:ln>
                               <a:noFill/>
@@ -3914,10 +3914,10 @@
                             <a:ea typeface="Cambria Math" panose="02040503050406030204" pitchFamily="18" charset="0"/>
                             <a:cs typeface="+mn-cs"/>
                           </a:rPr>
-                        </ns5:ctrlPr>
-                      </ns5:sSubPr>
-                      <ns5:e>
-                        <ns5:r>
+                        </m:ctrlPr>
+                      </m:sSubPr>
+                      <m:e>
+                        <m:r>
                           <a:rPr kumimoji="0" lang="en-US" sz="1800" b="0" i="1" u="none" strike="noStrike" kern="1200" cap="none" spc="0" normalizeH="0" baseline="0" noProof="0" smtClean="0">
                             <a:ln>
                               <a:noFill/>
@@ -3932,11 +3932,11 @@
                             <a:ea typeface="Cambria Math" panose="02040503050406030204" pitchFamily="18" charset="0"/>
                             <a:cs typeface="+mn-cs"/>
                           </a:rPr>
-                          <ns5:t>𝐸𝑛𝑒𝑟𝑔𝑦</ns5:t>
-                        </ns5:r>
-                      </ns5:e>
-                      <ns5:sub>
-                        <ns5:r>
+                          <m:t>𝐸𝑛𝑒𝑟𝑔𝑦</m:t>
+                        </m:r>
+                      </m:e>
+                      <m:sub>
+                        <m:r>
                           <a:rPr kumimoji="0" lang="en-US" sz="1800" b="0" i="1" u="none" strike="noStrike" kern="1200" cap="none" spc="0" normalizeH="0" baseline="0" noProof="0" smtClean="0">
                             <a:ln>
                               <a:noFill/>
@@ -3951,12 +3951,12 @@
                             <a:ea typeface="Cambria Math" panose="02040503050406030204" pitchFamily="18" charset="0"/>
                             <a:cs typeface="+mn-cs"/>
                           </a:rPr>
-                          <ns5:t>𝑇𝑂𝑇𝐴𝐿</ns5:t>
-                        </ns5:r>
-                      </ns5:sub>
-                    </ns5:sSub>
-                  </ns5:oMath>
-                </ns4:m>
+                          <m:t>𝑇𝑂𝑇𝐴𝐿</m:t>
+                        </m:r>
+                      </m:sub>
+                    </m:sSub>
+                  </m:oMath>
+                </a14:m>
                 <a:r>
                   <a:rPr kumimoji="0" lang="en-US" sz="1800" b="0" i="0" u="none" strike="noStrike" kern="1200" cap="none" spc="0" normalizeH="0" baseline="0" noProof="0" dirty="0">
                     <a:ln>
@@ -3974,11 +3974,11 @@
                   </a:rPr>
                   <a:t> = </a:t>
                 </a:r>
-                <ns4:m>
-                  <ns5:oMath>
-                    <ns5:sSub>
-                      <ns5:sSubPr>
-                        <ns5:ctrlPr>
+                <a14:m>
+                  <m:oMath>
+                    <m:sSub>
+                      <m:sSubPr>
+                        <m:ctrlPr>
                           <a:rPr kumimoji="0" lang="en-US" sz="1800" b="0" i="1" u="none" strike="noStrike" kern="1200" cap="none" spc="0" normalizeH="0" baseline="0" noProof="0">
                             <a:ln>
                               <a:noFill/>
@@ -3993,10 +3993,10 @@
                             <a:ea typeface="Cambria Math" panose="02040503050406030204" pitchFamily="18" charset="0"/>
                             <a:cs typeface="+mn-cs"/>
                           </a:rPr>
-                        </ns5:ctrlPr>
-                      </ns5:sSubPr>
-                      <ns5:e>
-                        <ns5:r>
+                        </m:ctrlPr>
+                      </m:sSubPr>
+                      <m:e>
+                        <m:r>
                           <a:rPr kumimoji="0" lang="en-US" sz="1800" b="0" i="1" u="none" strike="noStrike" kern="1200" cap="none" spc="0" normalizeH="0" baseline="0" noProof="0">
                             <a:ln>
                               <a:noFill/>
@@ -4011,11 +4011,11 @@
                             <a:ea typeface="Cambria Math" panose="02040503050406030204" pitchFamily="18" charset="0"/>
                             <a:cs typeface="+mn-cs"/>
                           </a:rPr>
-                          <ns5:t>𝐸𝑛𝑒𝑟𝑔𝑦</ns5:t>
-                        </ns5:r>
-                      </ns5:e>
-                      <ns5:sub>
-                        <ns5:r>
+                          <m:t>𝐸𝑛𝑒𝑟𝑔𝑦</m:t>
+                        </m:r>
+                      </m:e>
+                      <m:sub>
+                        <m:r>
                           <a:rPr kumimoji="0" lang="en-US" sz="1800" b="0" i="1" u="none" strike="noStrike" kern="1200" cap="none" spc="0" normalizeH="0" baseline="0" noProof="0">
                             <a:ln>
                               <a:noFill/>
@@ -4030,12 +4030,12 @@
                             <a:ea typeface="Cambria Math" panose="02040503050406030204" pitchFamily="18" charset="0"/>
                             <a:cs typeface="+mn-cs"/>
                           </a:rPr>
-                          <ns5:t>𝐴𝑃𝑃𝐴𝑅𝐸𝑁𝑇</ns5:t>
-                        </ns5:r>
-                      </ns5:sub>
-                    </ns5:sSub>
-                  </ns5:oMath>
-                </ns4:m>
+                          <m:t>𝐴𝑃𝑃𝐴𝑅𝐸𝑁𝑇</m:t>
+                        </m:r>
+                      </m:sub>
+                    </m:sSub>
+                  </m:oMath>
+                </a14:m>
                 <a:r>
                   <a:rPr kumimoji="0" lang="en-US" sz="1800" b="0" i="0" u="none" strike="noStrike" kern="1200" cap="none" spc="0" normalizeH="0" baseline="0" noProof="0" dirty="0">
                     <a:ln>
@@ -4053,11 +4053,11 @@
                   </a:rPr>
                   <a:t> + </a:t>
                 </a:r>
-                <ns4:m>
-                  <ns5:oMath>
-                    <ns5:sSub>
-                      <ns5:sSubPr>
-                        <ns5:ctrlPr>
+                <a14:m>
+                  <m:oMath>
+                    <m:sSub>
+                      <m:sSubPr>
+                        <m:ctrlPr>
                           <a:rPr kumimoji="0" lang="en-US" sz="1800" b="0" i="1" u="none" strike="noStrike" kern="1200" cap="none" spc="0" normalizeH="0" baseline="0" noProof="0">
                             <a:ln>
                               <a:noFill/>
@@ -4072,10 +4072,10 @@
                             <a:ea typeface="Cambria Math" panose="02040503050406030204" pitchFamily="18" charset="0"/>
                             <a:cs typeface="+mn-cs"/>
                           </a:rPr>
-                        </ns5:ctrlPr>
-                      </ns5:sSubPr>
-                      <ns5:e>
-                        <ns5:r>
+                        </m:ctrlPr>
+                      </m:sSubPr>
+                      <m:e>
+                        <m:r>
                           <a:rPr kumimoji="0" lang="en-US" sz="1800" b="0" i="1" u="none" strike="noStrike" kern="1200" cap="none" spc="0" normalizeH="0" baseline="0" noProof="0">
                             <a:ln>
                               <a:noFill/>
@@ -4090,11 +4090,11 @@
                             <a:ea typeface="Cambria Math" panose="02040503050406030204" pitchFamily="18" charset="0"/>
                             <a:cs typeface="+mn-cs"/>
                           </a:rPr>
-                          <ns5:t>𝐸𝑛𝑒𝑟𝑔𝑦</ns5:t>
-                        </ns5:r>
-                      </ns5:e>
-                      <ns5:sub>
-                        <ns5:r>
+                          <m:t>𝐸𝑛𝑒𝑟𝑔𝑦</m:t>
+                        </m:r>
+                      </m:e>
+                      <m:sub>
+                        <m:r>
                           <a:rPr kumimoji="0" lang="en-US" sz="1800" b="0" i="1" u="none" strike="noStrike" kern="1200" cap="none" spc="0" normalizeH="0" baseline="0" noProof="0" smtClean="0">
                             <a:ln>
                               <a:noFill/>
@@ -4109,12 +4109,12 @@
                             <a:ea typeface="Cambria Math" panose="02040503050406030204" pitchFamily="18" charset="0"/>
                             <a:cs typeface="+mn-cs"/>
                           </a:rPr>
-                          <ns5:t>𝑆𝐻𝐼𝐸𝐿𝐷𝐸𝐷𝑣𝑖𝑎𝑆𝑈𝑃𝐸𝑅𝑃𝑂𝑆𝐼𝑇𝐼𝑂𝑁</ns5:t>
-                        </ns5:r>
-                      </ns5:sub>
-                    </ns5:sSub>
-                  </ns5:oMath>
-                </ns4:m>
+                          <m:t>𝑆𝐻𝐼𝐸𝐿𝐷𝐸𝐷𝑣𝑖𝑎𝑆𝑈𝑃𝐸𝑅𝑃𝑂𝑆𝐼𝑇𝐼𝑂𝑁</m:t>
+                        </m:r>
+                      </m:sub>
+                    </m:sSub>
+                  </m:oMath>
+                </a14:m>
                 <a:r>
                   <a:rPr kumimoji="0" lang="en-US" sz="1800" b="0" i="0" u="none" strike="noStrike" kern="1200" cap="none" spc="0" normalizeH="0" baseline="0" noProof="0" dirty="0">
                     <a:ln>
@@ -4136,50 +4136,7 @@
             </p:txBody>
           </p:sp>
         </ns2:Choice>
-        <ns2:Fallback>
-          <p:sp>
-            <p:nvSpPr>
-              <p:cNvPr id="2" name="TextBox 1">
-                <a:extLst>
-                  <a:ext uri="{FF2B5EF4-FFF2-40B4-BE49-F238E27FC236}">
-                    <a16:creationId id="{09ACD5B1-F579-BE46-A136-9763C9D36C66}"/>
-                  </a:ext>
-                </a:extLst>
-              </p:cNvPr>
-              <p:cNvSpPr txBox="1">
-                <a:spLocks noRot="1" noChangeAspect="1" noMove="1" noResize="1" noEditPoints="1" noAdjustHandles="1" noChangeArrowheads="1" noChangeShapeType="1" noTextEdit="1"/>
-              </p:cNvSpPr>
-              <p:nvPr/>
-            </p:nvSpPr>
-            <p:spPr>
-              <a:xfrm>
-                <a:off x="2693154" y="2369064"/>
-                <a:ext cx="6963894" cy="369332"/>
-              </a:xfrm>
-              <a:prstGeom prst="rect">
-                <a:avLst/>
-              </a:prstGeom>
-              <a:blipFill>
-                <a:blip r:embed="rId3"/>
-                <a:stretch>
-                  <a:fillRect l="-182" t="-6667" b="-26667"/>
-                </a:stretch>
-              </a:blipFill>
-            </p:spPr>
-            <p:txBody>
-              <a:bodyPr/>
-              <a:lstStyle/>
-              <a:p>
-                <a:r>
-                  <a:rPr lang="en-US">
-                    <a:noFill/>
-                  </a:rPr>
-                  <a:t> </a:t>
-                </a:r>
-              </a:p>
-            </p:txBody>
-          </p:sp>
-        </ns2:Fallback>
+        <ns2:Fallback/>
       </ns2:AlternateContent>
       <ns2:AlternateContent>
         <ns2:Choice Requires="a14">
@@ -4228,13 +4185,13 @@
                   <a:tabLst/>
                   <a:defRPr/>
                 </a:pPr>
-                <ns4:m>
-                  <ns5:oMathPara>
-                    <ns5:oMathParaPr>
-                      <ns5:jc ns5:val="centerGroup"/>
-                    </ns5:oMathParaPr>
-                    <ns5:oMath>
-                      <ns5:r>
+                <a14:m>
+                  <m:oMathPara>
+                    <m:oMathParaPr>
+                      <m:jc m:val="centerGroup"/>
+                    </m:oMathParaPr>
+                    <m:oMath>
+                      <m:r>
                         <a:rPr kumimoji="0" lang="en-US" sz="1800" b="0" i="1" u="none" strike="noStrike" kern="1200" cap="none" spc="0" normalizeH="0" baseline="0" noProof="0" smtClean="0">
                           <a:ln>
                             <a:noFill/>
@@ -4249,9 +4206,9 @@
                           <a:ea typeface="Cambria Math" panose="02040503050406030204" pitchFamily="18" charset="0"/>
                           <a:cs typeface="+mn-cs"/>
                         </a:rPr>
-                        <ns5:t>𝑁</ns5:t>
-                      </ns5:r>
-                      <ns5:r>
+                        <m:t>𝑁</m:t>
+                      </m:r>
+                      <m:r>
                         <a:rPr kumimoji="0" lang="en-US" sz="1800" b="0" i="1" u="none" strike="noStrike" kern="1200" cap="none" spc="0" normalizeH="0" baseline="0" noProof="0">
                           <a:ln>
                             <a:noFill/>
@@ -4266,9 +4223,9 @@
                           <a:ea typeface="Cambria Math" panose="02040503050406030204" pitchFamily="18" charset="0"/>
                           <a:cs typeface="+mn-cs"/>
                         </a:rPr>
-                        <ns5:t>𝑎𝑡𝑢𝑟𝑒</ns5:t>
-                      </ns5:r>
-                      <ns5:r>
+                        <m:t>𝑎𝑡𝑢𝑟𝑒</m:t>
+                      </m:r>
+                      <m:r>
                         <a:rPr kumimoji="0" lang="en-US" sz="1800" b="0" i="1" u="none" strike="noStrike" kern="1200" cap="none" spc="0" normalizeH="0" baseline="0" noProof="0">
                           <a:ln>
                             <a:noFill/>
@@ -4283,11 +4240,11 @@
                           <a:ea typeface="Cambria Math" panose="02040503050406030204" pitchFamily="18" charset="0"/>
                           <a:cs typeface="+mn-cs"/>
                         </a:rPr>
-                        <ns5:t> :</ns5:t>
-                      </ns5:r>
-                      <ns5:sSub>
-                        <ns5:sSubPr>
-                          <ns5:ctrlPr>
+                        <m:t> :</m:t>
+                      </m:r>
+                      <m:sSub>
+                        <m:sSubPr>
+                          <m:ctrlPr>
                             <a:rPr kumimoji="0" lang="en-US" sz="1800" b="0" i="1" u="none" strike="noStrike" kern="1200" cap="none" spc="0" normalizeH="0" baseline="0" noProof="0">
                               <a:ln>
                                 <a:noFill/>
@@ -4302,10 +4259,10 @@
                               <a:ea typeface="Cambria Math" panose="02040503050406030204" pitchFamily="18" charset="0"/>
                               <a:cs typeface="+mn-cs"/>
                             </a:rPr>
-                          </ns5:ctrlPr>
-                        </ns5:sSubPr>
-                        <ns5:e>
-                          <ns5:r>
+                          </m:ctrlPr>
+                        </m:sSubPr>
+                        <m:e>
+                          <m:r>
                             <a:rPr kumimoji="0" lang="en-US" sz="1800" b="0" i="1" u="none" strike="noStrike" kern="1200" cap="none" spc="0" normalizeH="0" baseline="0" noProof="0" smtClean="0">
                               <a:ln>
                                 <a:noFill/>
@@ -4320,9 +4277,9 @@
                               <a:ea typeface="Cambria Math" panose="02040503050406030204" pitchFamily="18" charset="0"/>
                               <a:cs typeface="+mn-cs"/>
                             </a:rPr>
-                            <ns5:t> </ns5:t>
-                          </ns5:r>
-                          <ns5:r>
+                            <m:t> </m:t>
+                          </m:r>
+                          <m:r>
                             <a:rPr kumimoji="0" lang="en-US" sz="1800" b="0" i="1" u="none" strike="noStrike" kern="1200" cap="none" spc="0" normalizeH="0" baseline="0" noProof="0">
                               <a:ln>
                                 <a:noFill/>
@@ -4337,11 +4294,11 @@
                               <a:ea typeface="Cambria Math" panose="02040503050406030204" pitchFamily="18" charset="0"/>
                               <a:cs typeface="+mn-cs"/>
                             </a:rPr>
-                            <ns5:t>𝐸𝑛𝑒𝑟𝑔𝑦</ns5:t>
-                          </ns5:r>
-                        </ns5:e>
-                        <ns5:sub>
-                          <ns5:r>
+                            <m:t>𝐸𝑛𝑒𝑟𝑔𝑦</m:t>
+                          </m:r>
+                        </m:e>
+                        <m:sub>
+                          <m:r>
                             <a:rPr kumimoji="0" lang="en-US" sz="1800" b="0" i="1" u="none" strike="noStrike" kern="1200" cap="none" spc="0" normalizeH="0" baseline="0" noProof="0">
                               <a:ln>
                                 <a:noFill/>
@@ -4356,11 +4313,11 @@
                               <a:ea typeface="Cambria Math" panose="02040503050406030204" pitchFamily="18" charset="0"/>
                               <a:cs typeface="+mn-cs"/>
                             </a:rPr>
-                            <ns5:t>𝐴𝑃𝑃𝐴𝑅𝐸𝑁𝑇</ns5:t>
-                          </ns5:r>
-                        </ns5:sub>
-                      </ns5:sSub>
-                      <ns5:r>
+                            <m:t>𝐴𝑃𝑃𝐴𝑅𝐸𝑁𝑇</m:t>
+                          </m:r>
+                        </m:sub>
+                      </m:sSub>
+                      <m:r>
                         <a:rPr kumimoji="0" lang="en-US" sz="1800" b="0" i="1" u="none" strike="noStrike" kern="1200" cap="none" spc="0" normalizeH="0" baseline="0" noProof="0" smtClean="0">
                           <a:ln>
                             <a:noFill/>
@@ -4375,9 +4332,9 @@
                           <a:ea typeface="Cambria Math" panose="02040503050406030204" pitchFamily="18" charset="0"/>
                           <a:cs typeface="+mn-cs"/>
                         </a:rPr>
-                        <ns5:t> </ns5:t>
-                      </ns5:r>
-                      <ns5:r>
+                        <m:t> </m:t>
+                      </m:r>
+                      <m:r>
                         <a:rPr kumimoji="0" lang="en-US" sz="1800" b="0" i="1" u="none" strike="noStrike" kern="1200" cap="none" spc="0" normalizeH="0" baseline="0" noProof="0">
                           <a:ln>
                             <a:noFill/>
@@ -4392,9 +4349,9 @@
                           <a:ea typeface="Cambria Math" panose="02040503050406030204" pitchFamily="18" charset="0"/>
                           <a:cs typeface="+mn-cs"/>
                         </a:rPr>
-                        <ns5:t>= </ns5:t>
-                      </ns5:r>
-                      <ns5:r>
+                        <m:t>= </m:t>
+                      </m:r>
+                      <m:r>
                         <a:rPr kumimoji="0" lang="en-US" sz="1800" b="0" i="1" u="none" strike="noStrike" kern="1200" cap="none" spc="0" normalizeH="0" baseline="0" noProof="0">
                           <a:ln>
                             <a:noFill/>
@@ -4409,12 +4366,12 @@
                           <a:ea typeface="Cambria Math" panose="02040503050406030204" pitchFamily="18" charset="0"/>
                           <a:cs typeface="+mn-cs"/>
                         </a:rPr>
-                        <ns5:t>𝑀𝑎𝑠𝑠</ns5:t>
-                      </ns5:r>
-                      <ns5:r>
-                        <ns5:rPr>
-                          <ns5:nor/>
-                        </ns5:rPr>
+                        <m:t>𝑀𝑎𝑠𝑠</m:t>
+                      </m:r>
+                      <m:r>
+                        <m:rPr>
+                          <m:nor/>
+                        </m:rPr>
                         <a:rPr kumimoji="0" lang="en-US" sz="1800" b="0" i="0" u="none" strike="noStrike" kern="1200" cap="none" spc="0" normalizeH="0" baseline="0" noProof="0" dirty="0">
                           <a:ln>
                             <a:noFill/>
@@ -4429,11 +4386,11 @@
                           <a:ea typeface="+mn-ea"/>
                           <a:cs typeface="+mn-cs"/>
                         </a:rPr>
-                        <ns5:t> ∗ </ns5:t>
-                      </ns5:r>
-                      <ns5:sSup>
-                        <ns5:sSupPr>
-                          <ns5:ctrlPr>
+                        <m:t> ∗ </m:t>
+                      </m:r>
+                      <m:sSup>
+                        <m:sSupPr>
+                          <m:ctrlPr>
                             <a:rPr kumimoji="0" lang="en-US" sz="1800" b="0" i="1" u="none" strike="noStrike" kern="1200" cap="none" spc="0" normalizeH="0" baseline="0" noProof="0">
                               <a:ln>
                                 <a:noFill/>
@@ -4448,10 +4405,10 @@
                               <a:ea typeface="+mn-ea"/>
                               <a:cs typeface="+mn-cs"/>
                             </a:rPr>
-                          </ns5:ctrlPr>
-                        </ns5:sSupPr>
-                        <ns5:e>
-                          <ns5:r>
+                          </m:ctrlPr>
+                        </m:sSupPr>
+                        <m:e>
+                          <m:r>
                             <a:rPr kumimoji="0" lang="en-US" sz="1800" b="0" i="1" u="none" strike="noStrike" kern="1200" cap="none" spc="0" normalizeH="0" baseline="0" noProof="0">
                               <a:ln>
                                 <a:noFill/>
@@ -4466,11 +4423,11 @@
                               <a:ea typeface="+mn-ea"/>
                               <a:cs typeface="+mn-cs"/>
                             </a:rPr>
-                            <ns5:t>𝑐</ns5:t>
-                          </ns5:r>
-                        </ns5:e>
-                        <ns5:sup>
-                          <ns5:r>
+                            <m:t>𝑐</m:t>
+                          </m:r>
+                        </m:e>
+                        <m:sup>
+                          <m:r>
                             <a:rPr kumimoji="0" lang="en-US" sz="1800" b="0" i="1" u="none" strike="noStrike" kern="1200" cap="none" spc="0" normalizeH="0" baseline="0" noProof="0">
                               <a:ln>
                                 <a:noFill/>
@@ -4485,14 +4442,14 @@
                               <a:ea typeface="+mn-ea"/>
                               <a:cs typeface="+mn-cs"/>
                             </a:rPr>
-                            <ns5:t>2</ns5:t>
-                          </ns5:r>
-                        </ns5:sup>
-                      </ns5:sSup>
-                      <ns5:r>
-                        <ns5:rPr>
-                          <ns5:nor/>
-                        </ns5:rPr>
+                            <m:t>2</m:t>
+                          </m:r>
+                        </m:sup>
+                      </m:sSup>
+                      <m:r>
+                        <m:rPr>
+                          <m:nor/>
+                        </m:rPr>
                         <a:rPr kumimoji="0" lang="en-US" sz="1800" b="0" i="0" u="none" strike="noStrike" kern="1200" cap="none" spc="0" normalizeH="0" baseline="0" noProof="0" dirty="0">
                           <a:ln>
                             <a:noFill/>
@@ -4507,11 +4464,11 @@
                           <a:ea typeface="+mn-ea"/>
                           <a:cs typeface="+mn-cs"/>
                         </a:rPr>
-                        <ns5:t> </ns5:t>
-                      </ns5:r>
-                    </ns5:oMath>
-                  </ns5:oMathPara>
-                </ns4:m>
+                        <m:t> </m:t>
+                      </m:r>
+                    </m:oMath>
+                  </m:oMathPara>
+                </a14:m>
                 <a:endParaRPr kumimoji="0" lang="en-US" sz="1800" b="0" i="0" u="none" strike="noStrike" kern="1200" cap="none" spc="0" normalizeH="0" baseline="0" noProof="0" dirty="0">
                   <a:ln>
                     <a:noFill/>
@@ -4530,50 +4487,7 @@
             </p:txBody>
           </p:sp>
         </ns2:Choice>
-        <ns2:Fallback>
-          <p:sp>
-            <p:nvSpPr>
-              <p:cNvPr id="4" name="TextBox 3">
-                <a:extLst>
-                  <a:ext uri="{FF2B5EF4-FFF2-40B4-BE49-F238E27FC236}">
-                    <a16:creationId id="{1F81FDB4-73FA-704E-B5D5-4BC4D73D775C}"/>
-                  </a:ext>
-                </a:extLst>
-              </p:cNvPr>
-              <p:cNvSpPr txBox="1">
-                <a:spLocks noRot="1" noChangeAspect="1" noMove="1" noResize="1" noEditPoints="1" noAdjustHandles="1" noChangeArrowheads="1" noChangeShapeType="1" noTextEdit="1"/>
-              </p:cNvSpPr>
-              <p:nvPr/>
-            </p:nvSpPr>
-            <p:spPr>
-              <a:xfrm>
-                <a:off x="4058368" y="1651873"/>
-                <a:ext cx="4233467" cy="369332"/>
-              </a:xfrm>
-              <a:prstGeom prst="rect">
-                <a:avLst/>
-              </a:prstGeom>
-              <a:blipFill>
-                <a:blip r:embed="rId4"/>
-                <a:stretch>
-                  <a:fillRect t="-6667" b="-16667"/>
-                </a:stretch>
-              </a:blipFill>
-            </p:spPr>
-            <p:txBody>
-              <a:bodyPr/>
-              <a:lstStyle/>
-              <a:p>
-                <a:r>
-                  <a:rPr lang="en-US">
-                    <a:noFill/>
-                  </a:rPr>
-                  <a:t> </a:t>
-                </a:r>
-              </a:p>
-            </p:txBody>
-          </p:sp>
-        </ns2:Fallback>
+        <ns2:Fallback/>
       </ns2:AlternateContent>
       <ns2:AlternateContent>
         <ns2:Choice Requires="a14">
@@ -4622,9 +4536,9 @@
                   <a:tabLst/>
                   <a:defRPr/>
                 </a:pPr>
-                <ns4:m>
-                  <ns5:oMath>
-                    <ns5:r>
+                <a14:m>
+                  <m:oMath>
+                    <m:r>
                       <a:rPr kumimoji="0" lang="en-US" sz="1800" b="0" i="1" u="none" strike="noStrike" kern="1200" cap="none" spc="0" normalizeH="0" baseline="0" noProof="0" smtClean="0">
                         <a:ln>
                           <a:noFill/>
@@ -4639,9 +4553,9 @@
                         <a:ea typeface="Cambria Math" panose="02040503050406030204" pitchFamily="18" charset="0"/>
                         <a:cs typeface="+mn-cs"/>
                       </a:rPr>
-                      <ns5:t>𝐸𝑖𝑛𝑠𝑡𝑒𝑖𝑛</ns5:t>
-                    </ns5:r>
-                    <ns5:r>
+                      <m:t>𝐸𝑖𝑛𝑠𝑡𝑒𝑖𝑛</m:t>
+                    </m:r>
+                    <m:r>
                       <a:rPr kumimoji="0" lang="en-US" sz="1800" b="0" i="1" u="none" strike="noStrike" kern="1200" cap="none" spc="0" normalizeH="0" baseline="0" noProof="0" smtClean="0">
                         <a:ln>
                           <a:noFill/>
@@ -4656,9 +4570,9 @@
                         <a:ea typeface="Cambria Math" panose="02040503050406030204" pitchFamily="18" charset="0"/>
                         <a:cs typeface="+mn-cs"/>
                       </a:rPr>
-                      <ns5:t> : </ns5:t>
-                    </ns5:r>
-                    <ns5:r>
+                      <m:t> : </m:t>
+                    </m:r>
+                    <m:r>
                       <a:rPr kumimoji="0" lang="en-US" sz="1800" b="0" i="1" u="none" strike="noStrike" kern="1200" cap="none" spc="0" normalizeH="0" baseline="0" noProof="0" smtClean="0">
                         <a:ln>
                           <a:noFill/>
@@ -4673,9 +4587,9 @@
                         <a:ea typeface="Cambria Math" panose="02040503050406030204" pitchFamily="18" charset="0"/>
                         <a:cs typeface="+mn-cs"/>
                       </a:rPr>
-                      <ns5:t>𝐸𝑛𝑒𝑟𝑔𝑦</ns5:t>
-                    </ns5:r>
-                    <ns5:r>
+                      <m:t>𝐸𝑛𝑒𝑟𝑔𝑦</m:t>
+                    </m:r>
+                    <m:r>
                       <a:rPr kumimoji="0" lang="en-US" sz="1800" b="0" i="1" u="none" strike="noStrike" kern="1200" cap="none" spc="0" normalizeH="0" baseline="0" noProof="0" smtClean="0">
                         <a:ln>
                           <a:noFill/>
@@ -4690,9 +4604,9 @@
                         <a:ea typeface="Cambria Math" panose="02040503050406030204" pitchFamily="18" charset="0"/>
                         <a:cs typeface="+mn-cs"/>
                       </a:rPr>
-                      <ns5:t>= </ns5:t>
-                    </ns5:r>
-                    <ns5:r>
+                      <m:t>= </m:t>
+                    </m:r>
+                    <m:r>
                       <a:rPr kumimoji="0" lang="en-US" sz="1800" b="0" i="1" u="none" strike="noStrike" kern="1200" cap="none" spc="0" normalizeH="0" baseline="0" noProof="0">
                         <a:ln>
                           <a:noFill/>
@@ -4707,10 +4621,10 @@
                         <a:ea typeface="Cambria Math" panose="02040503050406030204" pitchFamily="18" charset="0"/>
                         <a:cs typeface="+mn-cs"/>
                       </a:rPr>
-                      <ns5:t>𝑀𝑎𝑠𝑠</ns5:t>
-                    </ns5:r>
-                  </ns5:oMath>
-                </ns4:m>
+                      <m:t>𝑀𝑎𝑠𝑠</m:t>
+                    </m:r>
+                  </m:oMath>
+                </a14:m>
                 <a:r>
                   <a:rPr kumimoji="0" lang="en-US" sz="1800" b="0" i="0" u="none" strike="noStrike" kern="1200" cap="none" spc="0" normalizeH="0" baseline="0" noProof="0" dirty="0">
                     <a:ln>
@@ -4728,11 +4642,11 @@
                   </a:rPr>
                   <a:t> * </a:t>
                 </a:r>
-                <ns4:m>
-                  <ns5:oMath>
-                    <ns5:sSup>
-                      <ns5:sSupPr>
-                        <ns5:ctrlPr>
+                <a14:m>
+                  <m:oMath>
+                    <m:sSup>
+                      <m:sSupPr>
+                        <m:ctrlPr>
                           <a:rPr kumimoji="0" lang="en-US" sz="1800" b="0" i="1" u="none" strike="noStrike" kern="1200" cap="none" spc="0" normalizeH="0" baseline="0" noProof="0" smtClean="0">
                             <a:ln>
                               <a:noFill/>
@@ -4747,10 +4661,10 @@
                             <a:ea typeface="+mn-ea"/>
                             <a:cs typeface="+mn-cs"/>
                           </a:rPr>
-                        </ns5:ctrlPr>
-                      </ns5:sSupPr>
-                      <ns5:e>
-                        <ns5:r>
+                        </m:ctrlPr>
+                      </m:sSupPr>
+                      <m:e>
+                        <m:r>
                           <a:rPr kumimoji="0" lang="en-US" sz="1800" b="0" i="1" u="none" strike="noStrike" kern="1200" cap="none" spc="0" normalizeH="0" baseline="0" noProof="0" smtClean="0">
                             <a:ln>
                               <a:noFill/>
@@ -4765,11 +4679,11 @@
                             <a:ea typeface="+mn-ea"/>
                             <a:cs typeface="+mn-cs"/>
                           </a:rPr>
-                          <ns5:t>𝑐</ns5:t>
-                        </ns5:r>
-                      </ns5:e>
-                      <ns5:sup>
-                        <ns5:r>
+                          <m:t>𝑐</m:t>
+                        </m:r>
+                      </m:e>
+                      <m:sup>
+                        <m:r>
                           <a:rPr kumimoji="0" lang="en-US" sz="1800" b="0" i="1" u="none" strike="noStrike" kern="1200" cap="none" spc="0" normalizeH="0" baseline="0" noProof="0" smtClean="0">
                             <a:ln>
                               <a:noFill/>
@@ -4784,12 +4698,12 @@
                             <a:ea typeface="+mn-ea"/>
                             <a:cs typeface="+mn-cs"/>
                           </a:rPr>
-                          <ns5:t>2</ns5:t>
-                        </ns5:r>
-                      </ns5:sup>
-                    </ns5:sSup>
-                  </ns5:oMath>
-                </ns4:m>
+                          <m:t>2</m:t>
+                        </m:r>
+                      </m:sup>
+                    </m:sSup>
+                  </m:oMath>
+                </a14:m>
                 <a:r>
                   <a:rPr kumimoji="0" lang="en-US" sz="1800" b="0" i="0" u="none" strike="noStrike" kern="1200" cap="none" spc="0" normalizeH="0" baseline="0" noProof="0" dirty="0">
                     <a:ln>
@@ -4811,50 +4725,7 @@
             </p:txBody>
           </p:sp>
         </ns2:Choice>
-        <ns2:Fallback>
-          <p:sp>
-            <p:nvSpPr>
-              <p:cNvPr id="11" name="TextBox 10">
-                <a:extLst>
-                  <a:ext uri="{FF2B5EF4-FFF2-40B4-BE49-F238E27FC236}">
-                    <a16:creationId id="{4929D634-5CDA-EA4B-AB4E-C56D95412138}"/>
-                  </a:ext>
-                </a:extLst>
-              </p:cNvPr>
-              <p:cNvSpPr txBox="1">
-                <a:spLocks noRot="1" noChangeAspect="1" noMove="1" noResize="1" noEditPoints="1" noAdjustHandles="1" noChangeArrowheads="1" noChangeShapeType="1" noTextEdit="1"/>
-              </p:cNvSpPr>
-              <p:nvPr/>
-            </p:nvSpPr>
-            <p:spPr>
-              <a:xfrm>
-                <a:off x="4435747" y="934682"/>
-                <a:ext cx="3478709" cy="369332"/>
-              </a:xfrm>
-              <a:prstGeom prst="rect">
-                <a:avLst/>
-              </a:prstGeom>
-              <a:blipFill>
-                <a:blip r:embed="rId5"/>
-                <a:stretch>
-                  <a:fillRect t="-6667" b="-26667"/>
-                </a:stretch>
-              </a:blipFill>
-            </p:spPr>
-            <p:txBody>
-              <a:bodyPr/>
-              <a:lstStyle/>
-              <a:p>
-                <a:r>
-                  <a:rPr lang="en-US">
-                    <a:noFill/>
-                  </a:rPr>
-                  <a:t> </a:t>
-                </a:r>
-              </a:p>
-            </p:txBody>
-          </p:sp>
-        </ns2:Fallback>
+        <ns2:Fallback/>
       </ns2:AlternateContent>
       <ns2:AlternateContent>
         <ns2:Choice Requires="a14">
@@ -4905,13 +4776,13 @@
                   <a:tabLst/>
                   <a:defRPr/>
                 </a:pPr>
-                <ns4:m>
-                  <ns5:oMathPara>
-                    <ns5:oMathParaPr>
-                      <ns5:jc ns5:val="centerGroup"/>
-                    </ns5:oMathParaPr>
-                    <ns5:oMath>
-                      <ns5:r>
+                <a14:m>
+                  <m:oMathPara>
+                    <m:oMathParaPr>
+                      <m:jc m:val="centerGroup"/>
+                    </m:oMathParaPr>
+                    <m:oMath>
+                      <m:r>
                         <a:rPr kumimoji="0" lang="en-US" sz="1800" b="1" i="1" u="none" strike="noStrike" kern="1200" cap="none" spc="0" normalizeH="0" baseline="0" noProof="0" smtClean="0">
                           <a:ln>
                             <a:noFill/>
@@ -4926,9 +4797,9 @@
                           <a:ea typeface="Cambria Math" panose="02040503050406030204" pitchFamily="18" charset="0"/>
                           <a:cs typeface="+mn-cs"/>
                         </a:rPr>
-                        <ns5:t>𝑺𝒕𝒂𝒏𝒅𝒂𝒓𝒅</ns5:t>
-                      </ns5:r>
-                      <ns5:r>
+                        <m:t>𝑺𝒕𝒂𝒏𝒅𝒂𝒓𝒅</m:t>
+                      </m:r>
+                      <m:r>
                         <a:rPr kumimoji="0" lang="en-US" sz="1800" b="1" i="1" u="none" strike="noStrike" kern="1200" cap="none" spc="0" normalizeH="0" baseline="0" noProof="0" smtClean="0">
                           <a:ln>
                             <a:noFill/>
@@ -4943,9 +4814,9 @@
                           <a:ea typeface="Cambria Math" panose="02040503050406030204" pitchFamily="18" charset="0"/>
                           <a:cs typeface="+mn-cs"/>
                         </a:rPr>
-                        <ns5:t> </ns5:t>
-                      </ns5:r>
-                      <ns5:r>
+                        <m:t> </m:t>
+                      </m:r>
+                      <m:r>
                         <a:rPr kumimoji="0" lang="en-US" sz="1800" b="1" i="1" u="none" strike="noStrike" kern="1200" cap="none" spc="0" normalizeH="0" baseline="0" noProof="0" smtClean="0">
                           <a:ln>
                             <a:noFill/>
@@ -4960,9 +4831,9 @@
                           <a:ea typeface="Cambria Math" panose="02040503050406030204" pitchFamily="18" charset="0"/>
                           <a:cs typeface="+mn-cs"/>
                         </a:rPr>
-                        <ns5:t>𝒎𝒂𝒕𝒕𝒆𝒓</ns5:t>
-                      </ns5:r>
-                      <ns5:r>
+                        <m:t>𝒎𝒂𝒕𝒕𝒆𝒓</m:t>
+                      </m:r>
+                      <m:r>
                         <a:rPr kumimoji="0" lang="en-US" sz="1800" b="1" i="1" u="none" strike="noStrike" kern="1200" cap="none" spc="0" normalizeH="0" baseline="0" noProof="0" smtClean="0">
                           <a:ln>
                             <a:noFill/>
@@ -4977,9 +4848,9 @@
                           <a:ea typeface="Cambria Math" panose="02040503050406030204" pitchFamily="18" charset="0"/>
                           <a:cs typeface="+mn-cs"/>
                         </a:rPr>
-                        <ns5:t> </ns5:t>
-                      </ns5:r>
-                      <ns5:r>
+                        <m:t> </m:t>
+                      </m:r>
+                      <m:r>
                         <a:rPr kumimoji="0" lang="en-US" sz="1800" b="1" i="1" u="none" strike="noStrike" kern="1200" cap="none" spc="0" normalizeH="0" baseline="0" noProof="0" smtClean="0">
                           <a:ln>
                             <a:noFill/>
@@ -4994,9 +4865,9 @@
                           <a:ea typeface="Cambria Math" panose="02040503050406030204" pitchFamily="18" charset="0"/>
                           <a:cs typeface="+mn-cs"/>
                         </a:rPr>
-                        <ns5:t>𝒑𝒂𝒓𝒕𝒊𝒄𝒍𝒆</ns5:t>
-                      </ns5:r>
-                      <ns5:r>
+                        <m:t>𝒑𝒂𝒓𝒕𝒊𝒄𝒍𝒆</m:t>
+                      </m:r>
+                      <m:r>
                         <a:rPr kumimoji="0" lang="en-US" sz="1800" b="1" i="1" u="none" strike="noStrike" kern="1200" cap="none" spc="0" normalizeH="0" baseline="0" noProof="0" smtClean="0">
                           <a:ln>
                             <a:noFill/>
@@ -5011,9 +4882,9 @@
                           <a:ea typeface="Cambria Math" panose="02040503050406030204" pitchFamily="18" charset="0"/>
                           <a:cs typeface="+mn-cs"/>
                         </a:rPr>
-                        <ns5:t> </ns5:t>
-                      </ns5:r>
-                      <ns5:r>
+                        <m:t> </m:t>
+                      </m:r>
+                      <m:r>
                         <a:rPr kumimoji="0" lang="en-US" sz="1800" b="1" i="1" u="none" strike="noStrike" kern="1200" cap="none" spc="0" normalizeH="0" baseline="0" noProof="0" smtClean="0">
                           <a:ln>
                             <a:noFill/>
@@ -5028,9 +4899,9 @@
                           <a:ea typeface="Cambria Math" panose="02040503050406030204" pitchFamily="18" charset="0"/>
                           <a:cs typeface="+mn-cs"/>
                         </a:rPr>
-                        <ns5:t>𝒂𝒔𝒔𝒆𝒎𝒃𝒍𝒚</ns5:t>
-                      </ns5:r>
-                      <ns5:r>
+                        <m:t>𝒂𝒔𝒔𝒆𝒎𝒃𝒍𝒚</m:t>
+                      </m:r>
+                      <m:r>
                         <a:rPr kumimoji="0" lang="en-US" sz="1800" b="1" i="1" u="none" strike="noStrike" kern="1200" cap="none" spc="0" normalizeH="0" baseline="0" noProof="0" smtClean="0">
                           <a:ln>
                             <a:noFill/>
@@ -5045,9 +4916,9 @@
                           <a:ea typeface="Cambria Math" panose="02040503050406030204" pitchFamily="18" charset="0"/>
                           <a:cs typeface="+mn-cs"/>
                         </a:rPr>
-                        <ns5:t> </ns5:t>
-                      </ns5:r>
-                      <ns5:r>
+                        <m:t> </m:t>
+                      </m:r>
+                      <m:r>
                         <a:rPr kumimoji="0" lang="en-US" sz="1800" b="1" i="1" u="none" strike="noStrike" kern="1200" cap="none" spc="0" normalizeH="0" baseline="0" noProof="0" smtClean="0">
                           <a:ln>
                             <a:noFill/>
@@ -5062,9 +4933,9 @@
                           <a:ea typeface="Cambria Math" panose="02040503050406030204" pitchFamily="18" charset="0"/>
                           <a:cs typeface="+mn-cs"/>
                         </a:rPr>
-                        <ns5:t>𝒂𝒕</ns5:t>
-                      </ns5:r>
-                      <ns5:r>
+                        <m:t>𝒂𝒕</m:t>
+                      </m:r>
+                      <m:r>
                         <a:rPr kumimoji="0" lang="en-US" sz="1800" b="1" i="1" u="none" strike="noStrike" kern="1200" cap="none" spc="0" normalizeH="0" baseline="0" noProof="0" smtClean="0">
                           <a:ln>
                             <a:noFill/>
@@ -5079,9 +4950,9 @@
                           <a:ea typeface="Cambria Math" panose="02040503050406030204" pitchFamily="18" charset="0"/>
                           <a:cs typeface="+mn-cs"/>
                         </a:rPr>
-                        <ns5:t> </ns5:t>
-                      </ns5:r>
-                      <ns5:r>
+                        <m:t> </m:t>
+                      </m:r>
+                      <m:r>
                         <a:rPr kumimoji="0" lang="en-US" sz="1800" b="1" i="1" u="none" strike="noStrike" kern="1200" cap="none" spc="0" normalizeH="0" baseline="0" noProof="0" smtClean="0">
                           <a:ln>
                             <a:noFill/>
@@ -5096,9 +4967,9 @@
                           <a:ea typeface="Cambria Math" panose="02040503050406030204" pitchFamily="18" charset="0"/>
                           <a:cs typeface="+mn-cs"/>
                         </a:rPr>
-                        <ns5:t>𝒓𝒆𝒔𝒕</ns5:t>
-                      </ns5:r>
-                      <ns5:r>
+                        <m:t>𝒓𝒆𝒔𝒕</m:t>
+                      </m:r>
+                      <m:r>
                         <a:rPr kumimoji="0" lang="en-US" sz="1800" b="1" i="1" u="none" strike="noStrike" kern="1200" cap="none" spc="0" normalizeH="0" baseline="0" noProof="0" smtClean="0">
                           <a:ln>
                             <a:noFill/>
@@ -5113,9 +4984,9 @@
                           <a:ea typeface="Cambria Math" panose="02040503050406030204" pitchFamily="18" charset="0"/>
                           <a:cs typeface="+mn-cs"/>
                         </a:rPr>
-                        <ns5:t> </ns5:t>
-                      </ns5:r>
-                      <ns5:r>
+                        <m:t> </m:t>
+                      </m:r>
+                      <m:r>
                         <a:rPr kumimoji="0" lang="en-US" sz="1800" b="1" i="1" u="none" strike="noStrike" kern="1200" cap="none" spc="0" normalizeH="0" baseline="0" noProof="0" smtClean="0">
                           <a:ln>
                             <a:noFill/>
@@ -5130,9 +5001,9 @@
                           <a:ea typeface="Cambria Math" panose="02040503050406030204" pitchFamily="18" charset="0"/>
                           <a:cs typeface="+mn-cs"/>
                         </a:rPr>
-                        <ns5:t>𝒊𝒏</ns5:t>
-                      </ns5:r>
-                      <ns5:r>
+                        <m:t>𝒊𝒏</m:t>
+                      </m:r>
+                      <m:r>
                         <a:rPr kumimoji="0" lang="en-US" sz="1800" b="1" i="1" u="none" strike="noStrike" kern="1200" cap="none" spc="0" normalizeH="0" baseline="0" noProof="0" smtClean="0">
                           <a:ln>
                             <a:noFill/>
@@ -5147,9 +5018,9 @@
                           <a:ea typeface="Cambria Math" panose="02040503050406030204" pitchFamily="18" charset="0"/>
                           <a:cs typeface="+mn-cs"/>
                         </a:rPr>
-                        <ns5:t> </ns5:t>
-                      </ns5:r>
-                      <ns5:r>
+                        <m:t> </m:t>
+                      </m:r>
+                      <m:r>
                         <a:rPr kumimoji="0" lang="en-US" sz="1800" b="1" i="1" u="none" strike="noStrike" kern="1200" cap="none" spc="0" normalizeH="0" baseline="0" noProof="0" smtClean="0">
                           <a:ln>
                             <a:noFill/>
@@ -5164,9 +5035,9 @@
                           <a:ea typeface="Cambria Math" panose="02040503050406030204" pitchFamily="18" charset="0"/>
                           <a:cs typeface="+mn-cs"/>
                         </a:rPr>
-                        <ns5:t>𝒕𝒉𝒆</ns5:t>
-                      </ns5:r>
-                      <ns5:r>
+                        <m:t>𝒕𝒉𝒆</m:t>
+                      </m:r>
+                      <m:r>
                         <a:rPr kumimoji="0" lang="en-US" sz="1800" b="1" i="1" u="none" strike="noStrike" kern="1200" cap="none" spc="0" normalizeH="0" baseline="0" noProof="0" smtClean="0">
                           <a:ln>
                             <a:noFill/>
@@ -5181,9 +5052,9 @@
                           <a:ea typeface="Cambria Math" panose="02040503050406030204" pitchFamily="18" charset="0"/>
                           <a:cs typeface="+mn-cs"/>
                         </a:rPr>
-                        <ns5:t> </ns5:t>
-                      </ns5:r>
-                      <ns5:r>
+                        <m:t> </m:t>
+                      </m:r>
+                      <m:r>
                         <a:rPr kumimoji="0" lang="en-US" sz="1800" b="1" i="1" u="none" strike="noStrike" kern="1200" cap="none" spc="0" normalizeH="0" baseline="0" noProof="0" smtClean="0">
                           <a:ln>
                             <a:noFill/>
@@ -5198,11 +5069,11 @@
                           <a:ea typeface="Cambria Math" panose="02040503050406030204" pitchFamily="18" charset="0"/>
                           <a:cs typeface="+mn-cs"/>
                         </a:rPr>
-                        <ns5:t>𝒂𝒆𝒕𝒉𝒆𝒓</ns5:t>
-                      </ns5:r>
-                    </ns5:oMath>
-                  </ns5:oMathPara>
-                </ns4:m>
+                        <m:t>𝒂𝒆𝒕𝒉𝒆𝒓</m:t>
+                      </m:r>
+                    </m:oMath>
+                  </m:oMathPara>
+                </a14:m>
                 <a:endParaRPr kumimoji="0" lang="en-US" sz="1800" b="1" i="0" u="none" strike="noStrike" kern="1200" cap="none" spc="0" normalizeH="0" baseline="0" noProof="0" dirty="0">
                   <a:ln>
                     <a:noFill/>
@@ -5221,50 +5092,7 @@
             </p:txBody>
           </p:sp>
         </ns2:Choice>
-        <ns2:Fallback>
-          <p:sp>
-            <p:nvSpPr>
-              <p:cNvPr id="14" name="TextBox 13">
-                <a:extLst>
-                  <a:ext uri="{FF2B5EF4-FFF2-40B4-BE49-F238E27FC236}">
-                    <a16:creationId id="{E13AC0F3-5C34-2644-BA21-4D36596EADBA}"/>
-                  </a:ext>
-                </a:extLst>
-              </p:cNvPr>
-              <p:cNvSpPr txBox="1">
-                <a:spLocks noRot="1" noChangeAspect="1" noMove="1" noResize="1" noEditPoints="1" noAdjustHandles="1" noChangeArrowheads="1" noChangeShapeType="1" noTextEdit="1"/>
-              </p:cNvSpPr>
-              <p:nvPr/>
-            </p:nvSpPr>
-            <p:spPr>
-              <a:xfrm>
-                <a:off x="2705240" y="245304"/>
-                <a:ext cx="6591869" cy="369332"/>
-              </a:xfrm>
-              <a:prstGeom prst="rect">
-                <a:avLst/>
-              </a:prstGeom>
-              <a:blipFill>
-                <a:blip r:embed="rId6"/>
-                <a:stretch>
-                  <a:fillRect b="-16667"/>
-                </a:stretch>
-              </a:blipFill>
-            </p:spPr>
-            <p:txBody>
-              <a:bodyPr/>
-              <a:lstStyle/>
-              <a:p>
-                <a:r>
-                  <a:rPr lang="en-US">
-                    <a:noFill/>
-                  </a:rPr>
-                  <a:t> </a:t>
-                </a:r>
-              </a:p>
-            </p:txBody>
-          </p:sp>
-        </ns2:Fallback>
+        <ns2:Fallback/>
       </ns2:AlternateContent>
       <ns2:AlternateContent>
         <ns2:Choice Requires="a14">
@@ -5313,11 +5141,11 @@
                   <a:tabLst/>
                   <a:defRPr/>
                 </a:pPr>
-                <ns4:m>
-                  <ns5:oMath>
-                    <ns5:sSub>
-                      <ns5:sSubPr>
-                        <ns5:ctrlPr>
+                <a14:m>
+                  <m:oMath>
+                    <m:sSub>
+                      <m:sSubPr>
+                        <m:ctrlPr>
                           <a:rPr kumimoji="0" lang="en-US" sz="1800" b="0" i="1" u="none" strike="noStrike" kern="1200" cap="none" spc="0" normalizeH="0" baseline="0" noProof="0" smtClean="0">
                             <a:ln>
                               <a:noFill/>
@@ -5332,10 +5160,10 @@
                             <a:ea typeface="Cambria Math" panose="02040503050406030204" pitchFamily="18" charset="0"/>
                             <a:cs typeface="+mn-cs"/>
                           </a:rPr>
-                        </ns5:ctrlPr>
-                      </ns5:sSubPr>
-                      <ns5:e>
-                        <ns5:r>
+                        </m:ctrlPr>
+                      </m:sSubPr>
+                      <m:e>
+                        <m:r>
                           <a:rPr kumimoji="0" lang="en-US" sz="1800" b="0" i="1" u="none" strike="noStrike" kern="1200" cap="none" spc="0" normalizeH="0" baseline="0" noProof="0">
                             <a:ln>
                               <a:noFill/>
@@ -5350,11 +5178,11 @@
                             <a:ea typeface="Cambria Math" panose="02040503050406030204" pitchFamily="18" charset="0"/>
                             <a:cs typeface="+mn-cs"/>
                           </a:rPr>
-                          <ns5:t>𝐸𝑛𝑒𝑟𝑔𝑦</ns5:t>
-                        </ns5:r>
-                      </ns5:e>
-                      <ns5:sub>
-                        <ns5:r>
+                          <m:t>𝐸𝑛𝑒𝑟𝑔𝑦</m:t>
+                        </m:r>
+                      </m:e>
+                      <m:sub>
+                        <m:r>
                           <a:rPr kumimoji="0" lang="en-US" sz="1800" b="0" i="1" u="none" strike="noStrike" kern="1200" cap="none" spc="0" normalizeH="0" baseline="0" noProof="0">
                             <a:ln>
                               <a:noFill/>
@@ -5369,11 +5197,11 @@
                             <a:ea typeface="Cambria Math" panose="02040503050406030204" pitchFamily="18" charset="0"/>
                             <a:cs typeface="+mn-cs"/>
                           </a:rPr>
-                          <ns5:t>𝑇𝑂𝑇𝐴𝐿</ns5:t>
-                        </ns5:r>
-                      </ns5:sub>
-                    </ns5:sSub>
-                    <ns5:r>
+                          <m:t>𝑇𝑂𝑇𝐴𝐿</m:t>
+                        </m:r>
+                      </m:sub>
+                    </m:sSub>
+                    <m:r>
                       <a:rPr kumimoji="0" lang="en-US" sz="1800" b="0" i="1" u="none" strike="noStrike" kern="1200" cap="none" spc="0" normalizeH="0" baseline="0" noProof="0" smtClean="0">
                         <a:ln>
                           <a:noFill/>
@@ -5388,11 +5216,11 @@
                         <a:ea typeface="Cambria Math" panose="02040503050406030204" pitchFamily="18" charset="0"/>
                         <a:cs typeface="+mn-cs"/>
                       </a:rPr>
-                      <ns5:t> =</ns5:t>
-                    </ns5:r>
-                    <ns5:sSub>
-                      <ns5:sSubPr>
-                        <ns5:ctrlPr>
+                      <m:t> =</m:t>
+                    </m:r>
+                    <m:sSub>
+                      <m:sSubPr>
+                        <m:ctrlPr>
                           <a:rPr kumimoji="0" lang="en-US" sz="1800" b="0" i="1" u="none" strike="noStrike" kern="1200" cap="none" spc="0" normalizeH="0" baseline="0" noProof="0">
                             <a:ln>
                               <a:noFill/>
@@ -5407,10 +5235,10 @@
                             <a:ea typeface="Cambria Math" panose="02040503050406030204" pitchFamily="18" charset="0"/>
                             <a:cs typeface="+mn-cs"/>
                           </a:rPr>
-                        </ns5:ctrlPr>
-                      </ns5:sSubPr>
-                      <ns5:e>
-                        <ns5:r>
+                        </m:ctrlPr>
+                      </m:sSubPr>
+                      <m:e>
+                        <m:r>
                           <a:rPr kumimoji="0" lang="en-US" sz="1800" b="0" i="1" u="none" strike="noStrike" kern="1200" cap="none" spc="0" normalizeH="0" baseline="0" noProof="0">
                             <a:ln>
                               <a:noFill/>
@@ -5425,11 +5253,11 @@
                             <a:ea typeface="Cambria Math" panose="02040503050406030204" pitchFamily="18" charset="0"/>
                             <a:cs typeface="+mn-cs"/>
                           </a:rPr>
-                          <ns5:t>𝐸𝑛𝑒𝑟𝑔𝑦</ns5:t>
-                        </ns5:r>
-                      </ns5:e>
-                      <ns5:sub>
-                        <ns5:r>
+                          <m:t>𝐸𝑛𝑒𝑟𝑔𝑦</m:t>
+                        </m:r>
+                      </m:e>
+                      <m:sub>
+                        <m:r>
                           <a:rPr kumimoji="0" lang="en-US" sz="1800" b="0" i="1" u="none" strike="noStrike" kern="1200" cap="none" spc="0" normalizeH="0" baseline="0" noProof="0">
                             <a:ln>
                               <a:noFill/>
@@ -5444,12 +5272,12 @@
                             <a:ea typeface="Cambria Math" panose="02040503050406030204" pitchFamily="18" charset="0"/>
                             <a:cs typeface="+mn-cs"/>
                           </a:rPr>
-                          <ns5:t>𝐴𝑃𝑃𝐴𝑅𝐸𝑁𝑇</ns5:t>
-                        </ns5:r>
-                      </ns5:sub>
-                    </ns5:sSub>
-                  </ns5:oMath>
-                </ns4:m>
+                          <m:t>𝐴𝑃𝑃𝐴𝑅𝐸𝑁𝑇</m:t>
+                        </m:r>
+                      </m:sub>
+                    </m:sSub>
+                  </m:oMath>
+                </a14:m>
                 <a:r>
                   <a:rPr kumimoji="0" lang="en-US" sz="1800" b="0" i="0" u="none" strike="noStrike" kern="1200" cap="none" spc="0" normalizeH="0" baseline="0" noProof="0" dirty="0">
                     <a:ln>
@@ -5467,11 +5295,11 @@
                   </a:rPr>
                   <a:t> = </a:t>
                 </a:r>
-                <ns4:m>
-                  <ns5:oMath>
-                    <ns5:sSup>
-                      <ns5:sSupPr>
-                        <ns5:ctrlPr>
+                <a14:m>
+                  <m:oMath>
+                    <m:sSup>
+                      <m:sSupPr>
+                        <m:ctrlPr>
                           <a:rPr kumimoji="0" lang="en-US" sz="1800" b="0" i="1" u="none" strike="noStrike" kern="1200" cap="none" spc="0" normalizeH="0" baseline="0" noProof="0" smtClean="0">
                             <a:ln>
                               <a:noFill/>
@@ -5486,10 +5314,10 @@
                             <a:ea typeface="+mn-ea"/>
                             <a:cs typeface="+mn-cs"/>
                           </a:rPr>
-                        </ns5:ctrlPr>
-                      </ns5:sSupPr>
-                      <ns5:e>
-                        <ns5:r>
+                        </m:ctrlPr>
+                      </m:sSupPr>
+                      <m:e>
+                        <m:r>
                           <a:rPr kumimoji="0" lang="en-US" sz="1800" b="0" i="1" u="none" strike="noStrike" kern="1200" cap="none" spc="0" normalizeH="0" baseline="0" noProof="0" smtClean="0">
                             <a:ln>
                               <a:noFill/>
@@ -5504,9 +5332,9 @@
                             <a:ea typeface="+mn-ea"/>
                             <a:cs typeface="+mn-cs"/>
                           </a:rPr>
-                          <ns5:t>𝑞</ns5:t>
-                        </ns5:r>
-                        <ns5:r>
+                          <m:t>𝑞</m:t>
+                        </m:r>
+                        <m:r>
                           <a:rPr kumimoji="0" lang="en-US" sz="1800" b="0" i="1" u="none" strike="noStrike" kern="1200" cap="none" spc="0" normalizeH="0" baseline="0" noProof="0" smtClean="0">
                             <a:ln>
                               <a:noFill/>
@@ -5521,11 +5349,11 @@
                             <a:ea typeface="+mn-ea"/>
                             <a:cs typeface="+mn-cs"/>
                           </a:rPr>
-                          <ns5:t> ∗ @</ns5:t>
-                        </ns5:r>
-                      </ns5:e>
-                      <ns5:sup>
-                        <ns5:r>
+                          <m:t> ∗ @</m:t>
+                        </m:r>
+                      </m:e>
+                      <m:sup>
+                        <m:r>
                           <a:rPr kumimoji="0" lang="en-US" sz="1800" b="0" i="1" u="none" strike="noStrike" kern="1200" cap="none" spc="0" normalizeH="0" baseline="0" noProof="0" smtClean="0">
                             <a:ln>
                               <a:noFill/>
@@ -5540,12 +5368,12 @@
                             <a:ea typeface="+mn-ea"/>
                             <a:cs typeface="+mn-cs"/>
                           </a:rPr>
-                          <ns5:t>2</ns5:t>
-                        </ns5:r>
-                      </ns5:sup>
-                    </ns5:sSup>
-                  </ns5:oMath>
-                </ns4:m>
+                          <m:t>2</m:t>
+                        </m:r>
+                      </m:sup>
+                    </m:sSup>
+                  </m:oMath>
+                </a14:m>
                 <a:r>
                   <a:rPr kumimoji="0" lang="en-US" sz="1800" b="0" i="0" u="none" strike="noStrike" kern="1200" cap="none" spc="0" normalizeH="0" baseline="0" noProof="0" dirty="0">
                     <a:ln>
@@ -5567,50 +5395,7 @@
             </p:txBody>
           </p:sp>
         </ns2:Choice>
-        <ns2:Fallback>
-          <p:sp>
-            <p:nvSpPr>
-              <p:cNvPr id="16" name="TextBox 15">
-                <a:extLst>
-                  <a:ext uri="{FF2B5EF4-FFF2-40B4-BE49-F238E27FC236}">
-                    <a16:creationId id="{EE3E7794-1E88-FF47-B593-FD8ABD326D20}"/>
-                  </a:ext>
-                </a:extLst>
-              </p:cNvPr>
-              <p:cNvSpPr txBox="1">
-                <a:spLocks noRot="1" noChangeAspect="1" noMove="1" noResize="1" noEditPoints="1" noAdjustHandles="1" noChangeArrowheads="1" noChangeShapeType="1" noTextEdit="1"/>
-              </p:cNvSpPr>
-              <p:nvPr/>
-            </p:nvSpPr>
-            <p:spPr>
-              <a:xfrm>
-                <a:off x="3902331" y="4520636"/>
-                <a:ext cx="4545540" cy="369332"/>
-              </a:xfrm>
-              <a:prstGeom prst="rect">
-                <a:avLst/>
-              </a:prstGeom>
-              <a:blipFill>
-                <a:blip r:embed="rId7"/>
-                <a:stretch>
-                  <a:fillRect l="-279" t="-10345" b="-27586"/>
-                </a:stretch>
-              </a:blipFill>
-            </p:spPr>
-            <p:txBody>
-              <a:bodyPr/>
-              <a:lstStyle/>
-              <a:p>
-                <a:r>
-                  <a:rPr lang="en-US">
-                    <a:noFill/>
-                  </a:rPr>
-                  <a:t> </a:t>
-                </a:r>
-              </a:p>
-            </p:txBody>
-          </p:sp>
-        </ns2:Fallback>
+        <ns2:Fallback/>
       </ns2:AlternateContent>
       <ns2:AlternateContent>
         <ns2:Choice Requires="a14">
@@ -5659,9 +5444,9 @@
                   <a:tabLst/>
                   <a:defRPr/>
                 </a:pPr>
-                <ns4:m>
-                  <ns5:oMath>
-                    <ns5:r>
+                <a14:m>
+                  <m:oMath>
+                    <m:r>
                       <a:rPr kumimoji="0" lang="en-US" sz="1800" b="0" i="1" u="none" strike="noStrike" kern="1200" cap="none" spc="0" normalizeH="0" baseline="0" noProof="0" smtClean="0">
                         <a:ln>
                           <a:noFill/>
@@ -5676,9 +5461,9 @@
                         <a:ea typeface="Cambria Math" panose="02040503050406030204" pitchFamily="18" charset="0"/>
                         <a:cs typeface="+mn-cs"/>
                       </a:rPr>
-                      <ns5:t>𝐿𝑒𝑡</ns5:t>
-                    </ns5:r>
-                    <ns5:r>
+                      <m:t>𝐿𝑒𝑡</m:t>
+                    </m:r>
+                    <m:r>
                       <a:rPr kumimoji="0" lang="en-US" sz="1800" b="0" i="1" u="none" strike="noStrike" kern="1200" cap="none" spc="0" normalizeH="0" baseline="0" noProof="0">
                         <a:ln>
                           <a:noFill/>
@@ -5693,9 +5478,9 @@
                         <a:ea typeface="Cambria Math" panose="02040503050406030204" pitchFamily="18" charset="0"/>
                         <a:cs typeface="+mn-cs"/>
                       </a:rPr>
-                      <ns5:t> </ns5:t>
-                    </ns5:r>
-                    <ns5:r>
+                      <m:t> </m:t>
+                    </m:r>
+                    <m:r>
                       <a:rPr kumimoji="0" lang="en-US" sz="1800" b="0" i="1" u="none" strike="noStrike" kern="1200" cap="none" spc="0" normalizeH="0" baseline="0" noProof="0">
                         <a:ln>
                           <a:noFill/>
@@ -5710,9 +5495,9 @@
                         <a:ea typeface="Cambria Math" panose="02040503050406030204" pitchFamily="18" charset="0"/>
                         <a:cs typeface="+mn-cs"/>
                       </a:rPr>
-                      <ns5:t>𝑡h𝑒</ns5:t>
-                    </ns5:r>
-                    <ns5:r>
+                      <m:t>𝑡h𝑒</m:t>
+                    </m:r>
+                    <m:r>
                       <a:rPr kumimoji="0" lang="en-US" sz="1800" b="0" i="1" u="none" strike="noStrike" kern="1200" cap="none" spc="0" normalizeH="0" baseline="0" noProof="0">
                         <a:ln>
                           <a:noFill/>
@@ -5727,9 +5512,9 @@
                         <a:ea typeface="Cambria Math" panose="02040503050406030204" pitchFamily="18" charset="0"/>
                         <a:cs typeface="+mn-cs"/>
                       </a:rPr>
-                      <ns5:t> </ns5:t>
-                    </ns5:r>
-                    <ns5:r>
+                      <m:t> </m:t>
+                    </m:r>
+                    <m:r>
                       <a:rPr kumimoji="0" lang="en-US" sz="1800" b="0" i="1" u="none" strike="noStrike" kern="1200" cap="none" spc="0" normalizeH="0" baseline="0" noProof="0">
                         <a:ln>
                           <a:noFill/>
@@ -5744,9 +5529,9 @@
                         <a:ea typeface="Cambria Math" panose="02040503050406030204" pitchFamily="18" charset="0"/>
                         <a:cs typeface="+mn-cs"/>
                       </a:rPr>
-                      <ns5:t>𝑠𝑦𝑚𝑏𝑜𝑙</ns5:t>
-                    </ns5:r>
-                    <ns5:r>
+                      <m:t>𝑠𝑦𝑚𝑏𝑜𝑙</m:t>
+                    </m:r>
+                    <m:r>
                       <a:rPr kumimoji="0" lang="en-US" sz="1800" b="0" i="1" u="none" strike="noStrike" kern="1200" cap="none" spc="0" normalizeH="0" baseline="0" noProof="0">
                         <a:ln>
                           <a:noFill/>
@@ -5761,9 +5546,9 @@
                         <a:ea typeface="Cambria Math" panose="02040503050406030204" pitchFamily="18" charset="0"/>
                         <a:cs typeface="+mn-cs"/>
                       </a:rPr>
-                      <ns5:t> </ns5:t>
-                    </ns5:r>
-                    <ns5:r>
+                      <m:t> </m:t>
+                    </m:r>
+                    <m:r>
                       <a:rPr kumimoji="0" lang="en-US" sz="1800" b="1" i="1" u="none" strike="noStrike" kern="1200" cap="none" spc="0" normalizeH="0" baseline="0" noProof="0">
                         <a:ln>
                           <a:noFill/>
@@ -5778,9 +5563,9 @@
                         <a:ea typeface="Cambria Math" panose="02040503050406030204" pitchFamily="18" charset="0"/>
                         <a:cs typeface="+mn-cs"/>
                       </a:rPr>
-                      <ns5:t>@</ns5:t>
-                    </ns5:r>
-                    <ns5:r>
+                      <m:t>@</m:t>
+                    </m:r>
+                    <m:r>
                       <a:rPr kumimoji="0" lang="en-US" sz="1800" b="0" i="1" u="none" strike="noStrike" kern="1200" cap="none" spc="0" normalizeH="0" baseline="0" noProof="0">
                         <a:ln>
                           <a:noFill/>
@@ -5795,9 +5580,9 @@
                         <a:ea typeface="Cambria Math" panose="02040503050406030204" pitchFamily="18" charset="0"/>
                         <a:cs typeface="+mn-cs"/>
                       </a:rPr>
-                      <ns5:t> </ns5:t>
-                    </ns5:r>
-                    <ns5:r>
+                      <m:t> </m:t>
+                    </m:r>
+                    <m:r>
                       <a:rPr kumimoji="0" lang="en-US" sz="1800" b="0" i="1" u="none" strike="noStrike" kern="1200" cap="none" spc="0" normalizeH="0" baseline="0" noProof="0" smtClean="0">
                         <a:ln>
                           <a:noFill/>
@@ -5812,9 +5597,9 @@
                         <a:ea typeface="Cambria Math" panose="02040503050406030204" pitchFamily="18" charset="0"/>
                         <a:cs typeface="+mn-cs"/>
                       </a:rPr>
-                      <ns5:t>𝑐𝑜𝑟𝑟𝑒𝑠𝑝𝑜𝑛𝑑</ns5:t>
-                    </ns5:r>
-                    <ns5:r>
+                      <m:t>𝑐𝑜𝑟𝑟𝑒𝑠𝑝𝑜𝑛𝑑</m:t>
+                    </m:r>
+                    <m:r>
                       <a:rPr kumimoji="0" lang="en-US" sz="1800" b="0" i="1" u="none" strike="noStrike" kern="1200" cap="none" spc="0" normalizeH="0" baseline="0" noProof="0" smtClean="0">
                         <a:ln>
                           <a:noFill/>
@@ -5829,9 +5614,9 @@
                         <a:ea typeface="Cambria Math" panose="02040503050406030204" pitchFamily="18" charset="0"/>
                         <a:cs typeface="+mn-cs"/>
                       </a:rPr>
-                      <ns5:t> </ns5:t>
-                    </ns5:r>
-                    <ns5:r>
+                      <m:t> </m:t>
+                    </m:r>
+                    <m:r>
                       <a:rPr kumimoji="0" lang="en-US" sz="1800" b="0" i="1" u="none" strike="noStrike" kern="1200" cap="none" spc="0" normalizeH="0" baseline="0" noProof="0" smtClean="0">
                         <a:ln>
                           <a:noFill/>
@@ -5846,9 +5631,9 @@
                         <a:ea typeface="Cambria Math" panose="02040503050406030204" pitchFamily="18" charset="0"/>
                         <a:cs typeface="+mn-cs"/>
                       </a:rPr>
-                      <ns5:t>𝑡𝑜</ns5:t>
-                    </ns5:r>
-                    <ns5:r>
+                      <m:t>𝑡𝑜</m:t>
+                    </m:r>
+                    <m:r>
                       <a:rPr kumimoji="0" lang="en-US" sz="1800" b="0" i="1" u="none" strike="noStrike" kern="1200" cap="none" spc="0" normalizeH="0" baseline="0" noProof="0">
                         <a:ln>
                           <a:noFill/>
@@ -5863,9 +5648,9 @@
                         <a:ea typeface="Cambria Math" panose="02040503050406030204" pitchFamily="18" charset="0"/>
                         <a:cs typeface="+mn-cs"/>
                       </a:rPr>
-                      <ns5:t> </ns5:t>
-                    </ns5:r>
-                    <ns5:r>
+                      <m:t> </m:t>
+                    </m:r>
+                    <m:r>
                       <a:rPr kumimoji="0" lang="en-US" sz="1800" b="0" i="1" u="none" strike="noStrike" kern="1200" cap="none" spc="0" normalizeH="0" baseline="0" noProof="0">
                         <a:ln>
                           <a:noFill/>
@@ -5880,9 +5665,9 @@
                         <a:ea typeface="Cambria Math" panose="02040503050406030204" pitchFamily="18" charset="0"/>
                         <a:cs typeface="+mn-cs"/>
                       </a:rPr>
-                      <ns5:t>𝑡h𝑒</ns5:t>
-                    </ns5:r>
-                    <ns5:r>
+                      <m:t>𝑡h𝑒</m:t>
+                    </m:r>
+                    <m:r>
                       <a:rPr kumimoji="0" lang="en-US" sz="1800" b="0" i="1" u="none" strike="noStrike" kern="1200" cap="none" spc="0" normalizeH="0" baseline="0" noProof="0">
                         <a:ln>
                           <a:noFill/>
@@ -5897,9 +5682,9 @@
                         <a:ea typeface="Cambria Math" panose="02040503050406030204" pitchFamily="18" charset="0"/>
                         <a:cs typeface="+mn-cs"/>
                       </a:rPr>
-                      <ns5:t> </ns5:t>
-                    </ns5:r>
-                    <ns5:r>
+                      <m:t> </m:t>
+                    </m:r>
+                    <m:r>
                       <a:rPr kumimoji="0" lang="en-US" sz="1800" b="0" i="1" u="none" strike="noStrike" kern="1200" cap="none" spc="0" normalizeH="0" baseline="0" noProof="0">
                         <a:ln>
                           <a:noFill/>
@@ -5914,9 +5699,9 @@
                         <a:ea typeface="Cambria Math" panose="02040503050406030204" pitchFamily="18" charset="0"/>
                         <a:cs typeface="+mn-cs"/>
                       </a:rPr>
-                      <ns5:t>𝑢𝑛𝑖𝑣𝑒𝑟𝑠𝑎𝑙</ns5:t>
-                    </ns5:r>
-                    <ns5:r>
+                      <m:t>𝑢𝑛𝑖𝑣𝑒𝑟𝑠𝑎𝑙</m:t>
+                    </m:r>
+                    <m:r>
                       <a:rPr kumimoji="0" lang="en-US" sz="1800" b="0" i="1" u="none" strike="noStrike" kern="1200" cap="none" spc="0" normalizeH="0" baseline="0" noProof="0">
                         <a:ln>
                           <a:noFill/>
@@ -5931,9 +5716,9 @@
                         <a:ea typeface="Cambria Math" panose="02040503050406030204" pitchFamily="18" charset="0"/>
                         <a:cs typeface="+mn-cs"/>
                       </a:rPr>
-                      <ns5:t> </ns5:t>
-                    </ns5:r>
-                    <ns5:r>
+                      <m:t> </m:t>
+                    </m:r>
+                    <m:r>
                       <a:rPr kumimoji="0" lang="en-US" sz="1800" b="0" i="1" u="none" strike="noStrike" kern="1200" cap="none" spc="0" normalizeH="0" baseline="0" noProof="0">
                         <a:ln>
                           <a:noFill/>
@@ -5948,9 +5733,9 @@
                         <a:ea typeface="Cambria Math" panose="02040503050406030204" pitchFamily="18" charset="0"/>
                         <a:cs typeface="+mn-cs"/>
                       </a:rPr>
-                      <ns5:t>𝑐𝑜𝑛𝑠𝑡𝑎𝑛𝑡</ns5:t>
-                    </ns5:r>
-                    <ns5:r>
+                      <m:t>𝑐𝑜𝑛𝑠𝑡𝑎𝑛𝑡</m:t>
+                    </m:r>
+                    <m:r>
                       <a:rPr kumimoji="0" lang="en-US" sz="1800" b="0" i="1" u="none" strike="noStrike" kern="1200" cap="none" spc="0" normalizeH="0" baseline="0" noProof="0">
                         <a:ln>
                           <a:noFill/>
@@ -5965,9 +5750,9 @@
                         <a:ea typeface="Cambria Math" panose="02040503050406030204" pitchFamily="18" charset="0"/>
                         <a:cs typeface="+mn-cs"/>
                       </a:rPr>
-                      <ns5:t> </ns5:t>
-                    </ns5:r>
-                    <ns5:r>
+                      <m:t> </m:t>
+                    </m:r>
+                    <m:r>
                       <a:rPr kumimoji="0" lang="en-US" sz="1800" b="0" i="1" u="none" strike="noStrike" kern="1200" cap="none" spc="0" normalizeH="0" baseline="0" noProof="0">
                         <a:ln>
                           <a:noFill/>
@@ -5982,9 +5767,9 @@
                         <a:ea typeface="Cambria Math" panose="02040503050406030204" pitchFamily="18" charset="0"/>
                         <a:cs typeface="+mn-cs"/>
                       </a:rPr>
-                      <ns5:t>𝑠𝑝𝑒𝑒𝑑</ns5:t>
-                    </ns5:r>
-                    <ns5:r>
+                      <m:t>𝑠𝑝𝑒𝑒𝑑</m:t>
+                    </m:r>
+                    <m:r>
                       <a:rPr kumimoji="0" lang="en-US" sz="1800" b="0" i="1" u="none" strike="noStrike" kern="1200" cap="none" spc="0" normalizeH="0" baseline="0" noProof="0">
                         <a:ln>
                           <a:noFill/>
@@ -5999,9 +5784,9 @@
                         <a:ea typeface="Cambria Math" panose="02040503050406030204" pitchFamily="18" charset="0"/>
                         <a:cs typeface="+mn-cs"/>
                       </a:rPr>
-                      <ns5:t> </ns5:t>
-                    </ns5:r>
-                    <ns5:r>
+                      <m:t> </m:t>
+                    </m:r>
+                    <m:r>
                       <a:rPr kumimoji="0" lang="en-US" sz="1800" b="0" i="1" u="none" strike="noStrike" kern="1200" cap="none" spc="0" normalizeH="0" baseline="0" noProof="0">
                         <a:ln>
                           <a:noFill/>
@@ -6016,9 +5801,9 @@
                         <a:ea typeface="Cambria Math" panose="02040503050406030204" pitchFamily="18" charset="0"/>
                         <a:cs typeface="+mn-cs"/>
                       </a:rPr>
-                      <ns5:t>𝑜𝑓</ns5:t>
-                    </ns5:r>
-                    <ns5:r>
+                      <m:t>𝑜𝑓</m:t>
+                    </m:r>
+                    <m:r>
                       <a:rPr kumimoji="0" lang="en-US" sz="1800" b="0" i="1" u="none" strike="noStrike" kern="1200" cap="none" spc="0" normalizeH="0" baseline="0" noProof="0">
                         <a:ln>
                           <a:noFill/>
@@ -6033,9 +5818,9 @@
                         <a:ea typeface="Cambria Math" panose="02040503050406030204" pitchFamily="18" charset="0"/>
                         <a:cs typeface="+mn-cs"/>
                       </a:rPr>
-                      <ns5:t> </ns5:t>
-                    </ns5:r>
-                    <ns5:r>
+                      <m:t> </m:t>
+                    </m:r>
+                    <m:r>
                       <a:rPr kumimoji="0" lang="en-US" sz="1800" b="0" i="1" u="none" strike="noStrike" kern="1200" cap="none" spc="0" normalizeH="0" baseline="0" noProof="0" smtClean="0">
                         <a:ln>
                           <a:noFill/>
@@ -6050,9 +5835,9 @@
                         <a:ea typeface="Cambria Math" panose="02040503050406030204" pitchFamily="18" charset="0"/>
                         <a:cs typeface="+mn-cs"/>
                       </a:rPr>
-                      <ns5:t>𝑝𝑜𝑡𝑒𝑛𝑡𝑖𝑎𝑙</ns5:t>
-                    </ns5:r>
-                    <ns5:r>
+                      <m:t>𝑝𝑜𝑡𝑒𝑛𝑡𝑖𝑎𝑙</m:t>
+                    </m:r>
+                    <m:r>
                       <a:rPr kumimoji="0" lang="en-US" sz="1800" b="0" i="1" u="none" strike="noStrike" kern="1200" cap="none" spc="0" normalizeH="0" baseline="0" noProof="0" smtClean="0">
                         <a:ln>
                           <a:noFill/>
@@ -6067,9 +5852,9 @@
                         <a:ea typeface="Cambria Math" panose="02040503050406030204" pitchFamily="18" charset="0"/>
                         <a:cs typeface="+mn-cs"/>
                       </a:rPr>
-                      <ns5:t> </ns5:t>
-                    </ns5:r>
-                    <ns5:r>
+                      <m:t> </m:t>
+                    </m:r>
+                    <m:r>
                       <a:rPr kumimoji="0" lang="en-US" sz="1800" b="0" i="1" u="none" strike="noStrike" kern="1200" cap="none" spc="0" normalizeH="0" baseline="0" noProof="0" smtClean="0">
                         <a:ln>
                           <a:noFill/>
@@ -6084,10 +5869,10 @@
                         <a:ea typeface="Cambria Math" panose="02040503050406030204" pitchFamily="18" charset="0"/>
                         <a:cs typeface="+mn-cs"/>
                       </a:rPr>
-                      <ns5:t>𝑒𝑚𝑖𝑠𝑠𝑖𝑜𝑛𝑠</ns5:t>
-                    </ns5:r>
-                  </ns5:oMath>
-                </ns4:m>
+                      <m:t>𝑒𝑚𝑖𝑠𝑠𝑖𝑜𝑛𝑠</m:t>
+                    </m:r>
+                  </m:oMath>
+                </a14:m>
                 <a:r>
                   <a:rPr kumimoji="0" lang="en-US" sz="1800" b="0" i="0" u="none" strike="noStrike" kern="1200" cap="none" spc="0" normalizeH="0" baseline="0" noProof="0" dirty="0">
                     <a:ln>
@@ -6109,50 +5894,7 @@
             </p:txBody>
           </p:sp>
         </ns2:Choice>
-        <ns2:Fallback>
-          <p:sp>
-            <p:nvSpPr>
-              <p:cNvPr id="18" name="TextBox 17">
-                <a:extLst>
-                  <a:ext uri="{FF2B5EF4-FFF2-40B4-BE49-F238E27FC236}">
-                    <a16:creationId id="{E8F051DE-2A4B-0C4E-A0CC-04A871A02B3D}"/>
-                  </a:ext>
-                </a:extLst>
-              </p:cNvPr>
-              <p:cNvSpPr txBox="1">
-                <a:spLocks noRot="1" noChangeAspect="1" noMove="1" noResize="1" noEditPoints="1" noAdjustHandles="1" noChangeArrowheads="1" noChangeShapeType="1" noTextEdit="1"/>
-              </p:cNvSpPr>
-              <p:nvPr/>
-            </p:nvSpPr>
-            <p:spPr>
-              <a:xfrm>
-                <a:off x="1485772" y="3803446"/>
-                <a:ext cx="9030806" cy="369332"/>
-              </a:xfrm>
-              <a:prstGeom prst="rect">
-                <a:avLst/>
-              </a:prstGeom>
-              <a:blipFill>
-                <a:blip r:embed="rId8"/>
-                <a:stretch>
-                  <a:fillRect t="-6667" b="-26667"/>
-                </a:stretch>
-              </a:blipFill>
-            </p:spPr>
-            <p:txBody>
-              <a:bodyPr/>
-              <a:lstStyle/>
-              <a:p>
-                <a:r>
-                  <a:rPr lang="en-US">
-                    <a:noFill/>
-                  </a:rPr>
-                  <a:t> </a:t>
-                </a:r>
-              </a:p>
-            </p:txBody>
-          </p:sp>
-        </ns2:Fallback>
+        <ns2:Fallback/>
       </ns2:AlternateContent>
       <ns2:AlternateContent>
         <ns2:Choice Requires="a14">
@@ -6203,9 +5945,9 @@
                   <a:tabLst/>
                   <a:defRPr/>
                 </a:pPr>
-                <ns4:m>
-                  <ns5:oMath>
-                    <ns5:r>
+                <a14:m>
+                  <m:oMath>
+                    <m:r>
                       <a:rPr kumimoji="0" lang="en-US" sz="1800" b="1" i="1" u="none" strike="noStrike" kern="1200" cap="none" spc="0" normalizeH="0" baseline="0" noProof="0" smtClean="0">
                         <a:ln>
                           <a:noFill/>
@@ -6220,9 +5962,9 @@
                         <a:ea typeface="Cambria Math" panose="02040503050406030204" pitchFamily="18" charset="0"/>
                         <a:cs typeface="+mn-cs"/>
                       </a:rPr>
-                      <ns5:t>𝑷𝒐𝒊𝒏𝒕</ns5:t>
-                    </ns5:r>
-                    <ns5:r>
+                      <m:t>𝑷𝒐𝒊𝒏𝒕</m:t>
+                    </m:r>
+                    <m:r>
                       <a:rPr kumimoji="0" lang="en-US" sz="1800" b="1" i="1" u="none" strike="noStrike" kern="1200" cap="none" spc="0" normalizeH="0" baseline="0" noProof="0" smtClean="0">
                         <a:ln>
                           <a:noFill/>
@@ -6237,9 +5979,9 @@
                         <a:ea typeface="Cambria Math" panose="02040503050406030204" pitchFamily="18" charset="0"/>
                         <a:cs typeface="+mn-cs"/>
                       </a:rPr>
-                      <ns5:t> </ns5:t>
-                    </ns5:r>
-                    <ns5:r>
+                      <m:t> </m:t>
+                    </m:r>
+                    <m:r>
                       <a:rPr kumimoji="0" lang="en-US" sz="1800" b="1" i="1" u="none" strike="noStrike" kern="1200" cap="none" spc="0" normalizeH="0" baseline="0" noProof="0" smtClean="0">
                         <a:ln>
                           <a:noFill/>
@@ -6254,9 +5996,9 @@
                         <a:ea typeface="Cambria Math" panose="02040503050406030204" pitchFamily="18" charset="0"/>
                         <a:cs typeface="+mn-cs"/>
                       </a:rPr>
-                      <ns5:t>𝒑𝒐𝒕𝒆𝒏𝒕𝒊𝒂𝒍</ns5:t>
-                    </ns5:r>
-                    <ns5:r>
+                      <m:t>𝒑𝒐𝒕𝒆𝒏𝒕𝒊𝒂𝒍</m:t>
+                    </m:r>
+                    <m:r>
                       <a:rPr kumimoji="0" lang="en-US" sz="1800" b="1" i="1" u="none" strike="noStrike" kern="1200" cap="none" spc="0" normalizeH="0" baseline="0" noProof="0" smtClean="0">
                         <a:ln>
                           <a:noFill/>
@@ -6271,9 +6013,9 @@
                         <a:ea typeface="Cambria Math" panose="02040503050406030204" pitchFamily="18" charset="0"/>
                         <a:cs typeface="+mn-cs"/>
                       </a:rPr>
-                      <ns5:t> </ns5:t>
-                    </ns5:r>
-                    <ns5:r>
+                      <m:t> </m:t>
+                    </m:r>
+                    <m:r>
                       <a:rPr kumimoji="0" lang="en-US" sz="1800" b="1" i="1" u="none" strike="noStrike" kern="1200" cap="none" spc="0" normalizeH="0" baseline="0" noProof="0" smtClean="0">
                         <a:ln>
                           <a:noFill/>
@@ -6288,9 +6030,9 @@
                         <a:ea typeface="Cambria Math" panose="02040503050406030204" pitchFamily="18" charset="0"/>
                         <a:cs typeface="+mn-cs"/>
                       </a:rPr>
-                      <ns5:t>𝒊𝒔𝒐𝒍𝒂𝒕𝒆𝒅</ns5:t>
-                    </ns5:r>
-                    <ns5:r>
+                      <m:t>𝒊𝒔𝒐𝒍𝒂𝒕𝒆𝒅</m:t>
+                    </m:r>
+                    <m:r>
                       <a:rPr kumimoji="0" lang="en-US" sz="1800" b="1" i="1" u="none" strike="noStrike" kern="1200" cap="none" spc="0" normalizeH="0" baseline="0" noProof="0" smtClean="0">
                         <a:ln>
                           <a:noFill/>
@@ -6305,9 +6047,9 @@
                         <a:ea typeface="Cambria Math" panose="02040503050406030204" pitchFamily="18" charset="0"/>
                         <a:cs typeface="+mn-cs"/>
                       </a:rPr>
-                      <ns5:t> </ns5:t>
-                    </ns5:r>
-                    <ns5:r>
+                      <m:t> </m:t>
+                    </m:r>
+                    <m:r>
                       <a:rPr kumimoji="0" lang="en-US" sz="1800" b="1" i="1" u="none" strike="noStrike" kern="1200" cap="none" spc="0" normalizeH="0" baseline="0" noProof="0" smtClean="0">
                         <a:ln>
                           <a:noFill/>
@@ -6322,9 +6064,9 @@
                         <a:ea typeface="Cambria Math" panose="02040503050406030204" pitchFamily="18" charset="0"/>
                         <a:cs typeface="+mn-cs"/>
                       </a:rPr>
-                      <ns5:t>𝒊𝒏</ns5:t>
-                    </ns5:r>
-                    <ns5:r>
+                      <m:t>𝒊𝒏</m:t>
+                    </m:r>
+                    <m:r>
                       <a:rPr kumimoji="0" lang="en-US" sz="1800" b="1" i="1" u="none" strike="noStrike" kern="1200" cap="none" spc="0" normalizeH="0" baseline="0" noProof="0" smtClean="0">
                         <a:ln>
                           <a:noFill/>
@@ -6339,9 +6081,9 @@
                         <a:ea typeface="Cambria Math" panose="02040503050406030204" pitchFamily="18" charset="0"/>
                         <a:cs typeface="+mn-cs"/>
                       </a:rPr>
-                      <ns5:t> </ns5:t>
-                    </ns5:r>
-                    <ns5:r>
+                      <m:t> </m:t>
+                    </m:r>
+                    <m:r>
                       <a:rPr kumimoji="0" lang="en-US" sz="1800" b="1" i="1" u="none" strike="noStrike" kern="1200" cap="none" spc="0" normalizeH="0" baseline="0" noProof="0" smtClean="0">
                         <a:ln>
                           <a:noFill/>
@@ -6356,9 +6098,9 @@
                         <a:ea typeface="Cambria Math" panose="02040503050406030204" pitchFamily="18" charset="0"/>
                         <a:cs typeface="+mn-cs"/>
                       </a:rPr>
-                      <ns5:t>𝒂</ns5:t>
-                    </ns5:r>
-                    <ns5:r>
+                      <m:t>𝒂</m:t>
+                    </m:r>
+                    <m:r>
                       <a:rPr kumimoji="0" lang="en-US" sz="1800" b="1" i="1" u="none" strike="noStrike" kern="1200" cap="none" spc="0" normalizeH="0" baseline="0" noProof="0" smtClean="0">
                         <a:ln>
                           <a:noFill/>
@@ -6373,9 +6115,9 @@
                         <a:ea typeface="Cambria Math" panose="02040503050406030204" pitchFamily="18" charset="0"/>
                         <a:cs typeface="+mn-cs"/>
                       </a:rPr>
-                      <ns5:t> </ns5:t>
-                    </ns5:r>
-                    <ns5:r>
+                      <m:t> </m:t>
+                    </m:r>
+                    <m:r>
                       <a:rPr kumimoji="0" lang="en-US" sz="1800" b="1" i="1" u="none" strike="noStrike" kern="1200" cap="none" spc="0" normalizeH="0" baseline="0" noProof="0" smtClean="0">
                         <a:ln>
                           <a:noFill/>
@@ -6390,9 +6132,9 @@
                         <a:ea typeface="Cambria Math" panose="02040503050406030204" pitchFamily="18" charset="0"/>
                         <a:cs typeface="+mn-cs"/>
                       </a:rPr>
-                      <ns5:t>𝑬𝒖𝒄𝒍𝒊𝒅𝒆𝒂𝒏</ns5:t>
-                    </ns5:r>
-                    <ns5:r>
+                      <m:t>𝑬𝒖𝒄𝒍𝒊𝒅𝒆𝒂𝒏</m:t>
+                    </m:r>
+                    <m:r>
                       <a:rPr kumimoji="0" lang="en-US" sz="1800" b="1" i="1" u="none" strike="noStrike" kern="1200" cap="none" spc="0" normalizeH="0" baseline="0" noProof="0" smtClean="0">
                         <a:ln>
                           <a:noFill/>
@@ -6407,9 +6149,9 @@
                         <a:ea typeface="Cambria Math" panose="02040503050406030204" pitchFamily="18" charset="0"/>
                         <a:cs typeface="+mn-cs"/>
                       </a:rPr>
-                      <ns5:t> </ns5:t>
-                    </ns5:r>
-                    <ns5:r>
+                      <m:t> </m:t>
+                    </m:r>
+                    <m:r>
                       <a:rPr kumimoji="0" lang="en-US" sz="1800" b="1" i="1" u="none" strike="noStrike" kern="1200" cap="none" spc="0" normalizeH="0" baseline="0" noProof="0" smtClean="0">
                         <a:ln>
                           <a:noFill/>
@@ -6424,9 +6166,9 @@
                         <a:ea typeface="Cambria Math" panose="02040503050406030204" pitchFamily="18" charset="0"/>
                         <a:cs typeface="+mn-cs"/>
                       </a:rPr>
-                      <ns5:t>𝒗𝒐𝒊𝒅</ns5:t>
-                    </ns5:r>
-                    <ns5:r>
+                      <m:t>𝒗𝒐𝒊𝒅</m:t>
+                    </m:r>
+                    <m:r>
                       <a:rPr kumimoji="0" lang="en-US" sz="1800" b="1" i="1" u="none" strike="noStrike" kern="1200" cap="none" spc="0" normalizeH="0" baseline="0" noProof="0" smtClean="0">
                         <a:ln>
                           <a:noFill/>
@@ -6441,9 +6183,9 @@
                         <a:ea typeface="Cambria Math" panose="02040503050406030204" pitchFamily="18" charset="0"/>
                         <a:cs typeface="+mn-cs"/>
                       </a:rPr>
-                      <ns5:t> </ns5:t>
-                    </ns5:r>
-                    <ns5:r>
+                      <m:t> </m:t>
+                    </m:r>
+                    <m:r>
                       <a:rPr kumimoji="0" lang="en-US" sz="1800" b="1" i="1" u="none" strike="noStrike" kern="1200" cap="none" spc="0" normalizeH="0" baseline="0" noProof="0" smtClean="0">
                         <a:ln>
                           <a:noFill/>
@@ -6458,9 +6200,9 @@
                         <a:ea typeface="Cambria Math" panose="02040503050406030204" pitchFamily="18" charset="0"/>
                         <a:cs typeface="+mn-cs"/>
                       </a:rPr>
-                      <ns5:t>𝒐𝒇</ns5:t>
-                    </ns5:r>
-                    <ns5:r>
+                      <m:t>𝒐𝒇</m:t>
+                    </m:r>
+                    <m:r>
                       <a:rPr kumimoji="0" lang="en-US" sz="1800" b="1" i="1" u="none" strike="noStrike" kern="1200" cap="none" spc="0" normalizeH="0" baseline="0" noProof="0" smtClean="0">
                         <a:ln>
                           <a:noFill/>
@@ -6475,9 +6217,9 @@
                         <a:ea typeface="Cambria Math" panose="02040503050406030204" pitchFamily="18" charset="0"/>
                         <a:cs typeface="+mn-cs"/>
                       </a:rPr>
-                      <ns5:t> </ns5:t>
-                    </ns5:r>
-                    <ns5:r>
+                      <m:t> </m:t>
+                    </m:r>
+                    <m:r>
                       <a:rPr kumimoji="0" lang="en-US" sz="1800" b="1" i="1" u="none" strike="noStrike" kern="1200" cap="none" spc="0" normalizeH="0" baseline="0" noProof="0" smtClean="0">
                         <a:ln>
                           <a:noFill/>
@@ -6492,9 +6234,9 @@
                         <a:ea typeface="Cambria Math" panose="02040503050406030204" pitchFamily="18" charset="0"/>
                         <a:cs typeface="+mn-cs"/>
                       </a:rPr>
-                      <ns5:t>𝒔𝒑𝒂𝒄𝒆</ns5:t>
-                    </ns5:r>
-                    <ns5:r>
+                      <m:t>𝒔𝒑𝒂𝒄𝒆</m:t>
+                    </m:r>
+                    <m:r>
                       <a:rPr kumimoji="0" lang="en-US" sz="1800" b="1" i="1" u="none" strike="noStrike" kern="1200" cap="none" spc="0" normalizeH="0" baseline="0" noProof="0" smtClean="0">
                         <a:ln>
                           <a:noFill/>
@@ -6509,9 +6251,9 @@
                         <a:ea typeface="Cambria Math" panose="02040503050406030204" pitchFamily="18" charset="0"/>
                         <a:cs typeface="+mn-cs"/>
                       </a:rPr>
-                      <ns5:t> </ns5:t>
-                    </ns5:r>
-                    <ns5:r>
+                      <m:t> </m:t>
+                    </m:r>
+                    <m:r>
                       <a:rPr kumimoji="0" lang="en-US" sz="1800" b="1" i="1" u="none" strike="noStrike" kern="1200" cap="none" spc="0" normalizeH="0" baseline="0" noProof="0" smtClean="0">
                         <a:ln>
                           <a:noFill/>
@@ -6526,9 +6268,9 @@
                         <a:ea typeface="Cambria Math" panose="02040503050406030204" pitchFamily="18" charset="0"/>
                         <a:cs typeface="+mn-cs"/>
                       </a:rPr>
-                      <ns5:t>𝒂𝒏𝒅</ns5:t>
-                    </ns5:r>
-                    <ns5:r>
+                      <m:t>𝒂𝒏𝒅</m:t>
+                    </m:r>
+                    <m:r>
                       <a:rPr kumimoji="0" lang="en-US" sz="1800" b="1" i="1" u="none" strike="noStrike" kern="1200" cap="none" spc="0" normalizeH="0" baseline="0" noProof="0" smtClean="0">
                         <a:ln>
                           <a:noFill/>
@@ -6543,9 +6285,9 @@
                         <a:ea typeface="Cambria Math" panose="02040503050406030204" pitchFamily="18" charset="0"/>
                         <a:cs typeface="+mn-cs"/>
                       </a:rPr>
-                      <ns5:t> </ns5:t>
-                    </ns5:r>
-                    <ns5:r>
+                      <m:t> </m:t>
+                    </m:r>
+                    <m:r>
                       <a:rPr kumimoji="0" lang="en-US" sz="1800" b="1" i="1" u="none" strike="noStrike" kern="1200" cap="none" spc="0" normalizeH="0" baseline="0" noProof="0" smtClean="0">
                         <a:ln>
                           <a:noFill/>
@@ -6560,9 +6302,9 @@
                         <a:ea typeface="Cambria Math" panose="02040503050406030204" pitchFamily="18" charset="0"/>
                         <a:cs typeface="+mn-cs"/>
                       </a:rPr>
-                      <ns5:t>𝒕𝒊𝒎𝒆</ns5:t>
-                    </ns5:r>
-                    <ns5:r>
+                      <m:t>𝒕𝒊𝒎𝒆</m:t>
+                    </m:r>
+                    <m:r>
                       <a:rPr kumimoji="0" lang="en-US" sz="1800" b="1" i="1" u="none" strike="noStrike" kern="1200" cap="none" spc="0" normalizeH="0" baseline="0" noProof="0" smtClean="0">
                         <a:ln>
                           <a:noFill/>
@@ -6577,9 +6319,9 @@
                         <a:ea typeface="Cambria Math" panose="02040503050406030204" pitchFamily="18" charset="0"/>
                         <a:cs typeface="+mn-cs"/>
                       </a:rPr>
-                      <ns5:t> (</ns5:t>
-                    </ns5:r>
-                    <ns5:r>
+                      <m:t> (</m:t>
+                    </m:r>
+                    <m:r>
                       <a:rPr kumimoji="0" lang="en-US" sz="1800" b="1" i="1" u="none" strike="noStrike" kern="1200" cap="none" spc="0" normalizeH="0" baseline="0" noProof="0" smtClean="0">
                         <a:ln>
                           <a:noFill/>
@@ -6594,9 +6336,9 @@
                         <a:ea typeface="Cambria Math" panose="02040503050406030204" pitchFamily="18" charset="0"/>
                         <a:cs typeface="+mn-cs"/>
                       </a:rPr>
-                      <ns5:t>𝒗𝒆𝒍𝒐𝒄𝒊𝒕𝒚</ns5:t>
-                    </ns5:r>
-                    <ns5:r>
+                      <m:t>𝒗𝒆𝒍𝒐𝒄𝒊𝒕𝒚</m:t>
+                    </m:r>
+                    <m:r>
                       <a:rPr kumimoji="0" lang="en-US" sz="1800" b="1" i="1" u="none" strike="noStrike" kern="1200" cap="none" spc="0" normalizeH="0" baseline="0" noProof="0" smtClean="0">
                         <a:ln>
                           <a:noFill/>
@@ -6611,9 +6353,9 @@
                         <a:ea typeface="Cambria Math" panose="02040503050406030204" pitchFamily="18" charset="0"/>
                         <a:cs typeface="+mn-cs"/>
                       </a:rPr>
-                      <ns5:t> </ns5:t>
-                    </ns5:r>
-                    <ns5:r>
+                      <m:t> </m:t>
+                    </m:r>
+                    <m:r>
                       <a:rPr kumimoji="0" lang="en-US" sz="1800" b="1" i="1" u="none" strike="noStrike" kern="1200" cap="none" spc="0" normalizeH="0" baseline="0" noProof="0" smtClean="0">
                         <a:ln>
                           <a:noFill/>
@@ -6628,9 +6370,9 @@
                         <a:ea typeface="Cambria Math" panose="02040503050406030204" pitchFamily="18" charset="0"/>
                         <a:cs typeface="+mn-cs"/>
                       </a:rPr>
-                      <ns5:t>𝒏𝒐𝒕</ns5:t>
-                    </ns5:r>
-                    <ns5:r>
+                      <m:t>𝒏𝒐𝒕</m:t>
+                    </m:r>
+                    <m:r>
                       <a:rPr kumimoji="0" lang="en-US" sz="1800" b="1" i="1" u="none" strike="noStrike" kern="1200" cap="none" spc="0" normalizeH="0" baseline="0" noProof="0" smtClean="0">
                         <a:ln>
                           <a:noFill/>
@@ -6645,9 +6387,9 @@
                         <a:ea typeface="Cambria Math" panose="02040503050406030204" pitchFamily="18" charset="0"/>
                         <a:cs typeface="+mn-cs"/>
                       </a:rPr>
-                      <ns5:t> </ns5:t>
-                    </ns5:r>
-                    <ns5:r>
+                      <m:t> </m:t>
+                    </m:r>
+                    <m:r>
                       <a:rPr kumimoji="0" lang="en-US" sz="1800" b="1" i="1" u="none" strike="noStrike" kern="1200" cap="none" spc="0" normalizeH="0" baseline="0" noProof="0" smtClean="0">
                         <a:ln>
                           <a:noFill/>
@@ -6662,9 +6404,9 @@
                         <a:ea typeface="Cambria Math" panose="02040503050406030204" pitchFamily="18" charset="0"/>
                         <a:cs typeface="+mn-cs"/>
                       </a:rPr>
-                      <ns5:t>𝒅𝒆𝒇𝒊𝒏𝒆𝒅</ns5:t>
-                    </ns5:r>
-                    <ns5:r>
+                      <m:t>𝒅𝒆𝒇𝒊𝒏𝒆𝒅</m:t>
+                    </m:r>
+                    <m:r>
                       <a:rPr kumimoji="0" lang="en-US" sz="1800" b="1" i="1" u="none" strike="noStrike" kern="1200" cap="none" spc="0" normalizeH="0" baseline="0" noProof="0" smtClean="0">
                         <a:ln>
                           <a:noFill/>
@@ -6679,10 +6421,10 @@
                         <a:ea typeface="Cambria Math" panose="02040503050406030204" pitchFamily="18" charset="0"/>
                         <a:cs typeface="+mn-cs"/>
                       </a:rPr>
-                      <ns5:t>)</ns5:t>
-                    </ns5:r>
-                  </ns5:oMath>
-                </ns4:m>
+                      <m:t>)</m:t>
+                    </m:r>
+                  </m:oMath>
+                </a14:m>
                 <a:r>
                   <a:rPr kumimoji="0" lang="en-US" sz="1800" b="0" i="0" u="none" strike="noStrike" kern="1200" cap="none" spc="0" normalizeH="0" baseline="0" noProof="0" dirty="0">
                     <a:ln>
@@ -6704,50 +6446,7 @@
             </p:txBody>
           </p:sp>
         </ns2:Choice>
-        <ns2:Fallback>
-          <p:sp>
-            <p:nvSpPr>
-              <p:cNvPr id="20" name="TextBox 19">
-                <a:extLst>
-                  <a:ext uri="{FF2B5EF4-FFF2-40B4-BE49-F238E27FC236}">
-                    <a16:creationId id="{B3FFFA43-DC28-C04C-8FF8-72E533B0CF14}"/>
-                  </a:ext>
-                </a:extLst>
-              </p:cNvPr>
-              <p:cNvSpPr txBox="1">
-                <a:spLocks noRot="1" noChangeAspect="1" noMove="1" noResize="1" noEditPoints="1" noAdjustHandles="1" noChangeArrowheads="1" noChangeShapeType="1" noTextEdit="1"/>
-              </p:cNvSpPr>
-              <p:nvPr/>
-            </p:nvSpPr>
-            <p:spPr>
-              <a:xfrm>
-                <a:off x="1179767" y="3086255"/>
-                <a:ext cx="9990668" cy="369332"/>
-              </a:xfrm>
-              <a:prstGeom prst="rect">
-                <a:avLst/>
-              </a:prstGeom>
-              <a:blipFill>
-                <a:blip r:embed="rId9"/>
-                <a:stretch>
-                  <a:fillRect b="-12903"/>
-                </a:stretch>
-              </a:blipFill>
-            </p:spPr>
-            <p:txBody>
-              <a:bodyPr/>
-              <a:lstStyle/>
-              <a:p>
-                <a:r>
-                  <a:rPr lang="en-US">
-                    <a:noFill/>
-                  </a:rPr>
-                  <a:t> </a:t>
-                </a:r>
-              </a:p>
-            </p:txBody>
-          </p:sp>
-        </ns2:Fallback>
+        <ns2:Fallback/>
       </ns2:AlternateContent>
       <ns2:AlternateContent>
         <ns2:Choice Requires="a14">
@@ -6796,13 +6495,13 @@
                   <a:tabLst/>
                   <a:defRPr/>
                 </a:pPr>
-                <ns4:m>
-                  <ns5:oMathPara>
-                    <ns5:oMathParaPr>
-                      <ns5:jc ns5:val="centerGroup"/>
-                    </ns5:oMathParaPr>
-                    <ns5:oMath>
-                      <ns5:r>
+                <a14:m>
+                  <m:oMathPara>
+                    <m:oMathParaPr>
+                      <m:jc m:val="centerGroup"/>
+                    </m:oMathParaPr>
+                    <m:oMath>
+                      <m:r>
                         <a:rPr kumimoji="0" lang="en-US" sz="1800" b="1" i="1" u="none" strike="noStrike" kern="1200" cap="none" spc="0" normalizeH="0" baseline="0" noProof="0" smtClean="0">
                           <a:ln>
                             <a:noFill/>
@@ -6817,11 +6516,11 @@
                           <a:ea typeface="Cambria Math" panose="02040503050406030204" pitchFamily="18" charset="0"/>
                           <a:cs typeface="+mn-cs"/>
                         </a:rPr>
-                        <ns5:t>𝑫𝒖𝒂𝒍𝒊𝒕𝒚</ns5:t>
-                      </ns5:r>
-                    </ns5:oMath>
-                  </ns5:oMathPara>
-                </ns4:m>
+                        <m:t>𝑫𝒖𝒂𝒍𝒊𝒕𝒚</m:t>
+                      </m:r>
+                    </m:oMath>
+                  </m:oMathPara>
+                </a14:m>
                 <a:endParaRPr kumimoji="0" lang="en-US" sz="1800" b="0" i="1" u="none" strike="noStrike" kern="1200" cap="none" spc="0" normalizeH="0" baseline="0" noProof="0" dirty="0">
                   <a:ln>
                     <a:noFill/>
@@ -6855,13 +6554,13 @@
                   <a:tabLst/>
                   <a:defRPr/>
                 </a:pPr>
-                <ns4:m>
-                  <ns5:oMathPara>
-                    <ns5:oMathParaPr>
-                      <ns5:jc ns5:val="centerGroup"/>
-                    </ns5:oMathParaPr>
-                    <ns5:oMath>
-                      <ns5:r>
+                <a14:m>
+                  <m:oMathPara>
+                    <m:oMathParaPr>
+                      <m:jc m:val="centerGroup"/>
+                    </m:oMathParaPr>
+                    <m:oMath>
+                      <m:r>
                         <a:rPr kumimoji="0" lang="en-US" sz="1800" b="0" i="1" u="none" strike="noStrike" kern="1200" cap="none" spc="0" normalizeH="0" baseline="0" noProof="0">
                           <a:ln>
                             <a:noFill/>
@@ -6876,9 +6575,9 @@
                           <a:ea typeface="Cambria Math" panose="02040503050406030204" pitchFamily="18" charset="0"/>
                           <a:cs typeface="+mn-cs"/>
                         </a:rPr>
-                        <ns5:t>𝑃𝑜𝑖𝑛𝑡</ns5:t>
-                      </ns5:r>
-                      <ns5:r>
+                        <m:t>𝑃𝑜𝑖𝑛𝑡</m:t>
+                      </m:r>
+                      <m:r>
                         <a:rPr kumimoji="0" lang="en-US" sz="1800" b="0" i="1" u="none" strike="noStrike" kern="1200" cap="none" spc="0" normalizeH="0" baseline="0" noProof="0">
                           <a:ln>
                             <a:noFill/>
@@ -6893,9 +6592,9 @@
                           <a:ea typeface="Cambria Math" panose="02040503050406030204" pitchFamily="18" charset="0"/>
                           <a:cs typeface="+mn-cs"/>
                         </a:rPr>
-                        <ns5:t> </ns5:t>
-                      </ns5:r>
-                      <ns5:r>
+                        <m:t> </m:t>
+                      </m:r>
+                      <m:r>
                         <a:rPr kumimoji="0" lang="en-US" sz="1800" b="0" i="1" u="none" strike="noStrike" kern="1200" cap="none" spc="0" normalizeH="0" baseline="0" noProof="0" smtClean="0">
                           <a:ln>
                             <a:noFill/>
@@ -6910,9 +6609,9 @@
                           <a:ea typeface="Cambria Math" panose="02040503050406030204" pitchFamily="18" charset="0"/>
                           <a:cs typeface="+mn-cs"/>
                         </a:rPr>
-                        <ns5:t>𝑝𝑜𝑡𝑒𝑛𝑡𝑖𝑎𝑙</ns5:t>
-                      </ns5:r>
-                      <ns5:r>
+                        <m:t>𝑝𝑜𝑡𝑒𝑛𝑡𝑖𝑎𝑙</m:t>
+                      </m:r>
+                      <m:r>
                         <a:rPr kumimoji="0" lang="en-US" sz="1800" b="0" i="1" u="none" strike="noStrike" kern="1200" cap="none" spc="0" normalizeH="0" baseline="0" noProof="0">
                           <a:ln>
                             <a:noFill/>
@@ -6927,9 +6626,9 @@
                           <a:ea typeface="Cambria Math" panose="02040503050406030204" pitchFamily="18" charset="0"/>
                           <a:cs typeface="+mn-cs"/>
                         </a:rPr>
-                        <ns5:t> </ns5:t>
-                      </ns5:r>
-                      <ns5:r>
+                        <m:t> </m:t>
+                      </m:r>
+                      <m:r>
                         <a:rPr kumimoji="0" lang="en-US" sz="1800" b="0" i="1" u="none" strike="noStrike" kern="1200" cap="none" spc="0" normalizeH="0" baseline="0" noProof="0">
                           <a:ln>
                             <a:noFill/>
@@ -6944,9 +6643,9 @@
                           <a:ea typeface="Cambria Math" panose="02040503050406030204" pitchFamily="18" charset="0"/>
                           <a:cs typeface="+mn-cs"/>
                         </a:rPr>
-                        <ns5:t>𝑓𝑖𝑒𝑙𝑑𝑠</ns5:t>
-                      </ns5:r>
-                      <ns5:r>
+                        <m:t>𝑓𝑖𝑒𝑙𝑑𝑠</m:t>
+                      </m:r>
+                      <m:r>
                         <a:rPr kumimoji="0" lang="en-US" sz="1800" b="0" i="1" u="none" strike="noStrike" kern="1200" cap="none" spc="0" normalizeH="0" baseline="0" noProof="0">
                           <a:ln>
                             <a:noFill/>
@@ -6961,9 +6660,9 @@
                           <a:ea typeface="Cambria Math" panose="02040503050406030204" pitchFamily="18" charset="0"/>
                           <a:cs typeface="+mn-cs"/>
                         </a:rPr>
-                        <ns5:t> </ns5:t>
-                      </ns5:r>
-                      <ns5:r>
+                        <m:t> </m:t>
+                      </m:r>
+                      <m:r>
                         <a:rPr kumimoji="0" lang="en-US" sz="1800" b="0" i="1" u="none" strike="noStrike" kern="1200" cap="none" spc="0" normalizeH="0" baseline="0" noProof="0">
                           <a:ln>
                             <a:noFill/>
@@ -6978,9 +6677,9 @@
                           <a:ea typeface="Cambria Math" panose="02040503050406030204" pitchFamily="18" charset="0"/>
                           <a:cs typeface="+mn-cs"/>
                         </a:rPr>
-                        <ns5:t>𝑡𝑟𝑎𝑣𝑒𝑙</ns5:t>
-                      </ns5:r>
-                      <ns5:r>
+                        <m:t>𝑡𝑟𝑎𝑣𝑒𝑙</m:t>
+                      </m:r>
+                      <m:r>
                         <a:rPr kumimoji="0" lang="en-US" sz="1800" b="0" i="1" u="none" strike="noStrike" kern="1200" cap="none" spc="0" normalizeH="0" baseline="0" noProof="0">
                           <a:ln>
                             <a:noFill/>
@@ -6995,9 +6694,9 @@
                           <a:ea typeface="Cambria Math" panose="02040503050406030204" pitchFamily="18" charset="0"/>
                           <a:cs typeface="+mn-cs"/>
                         </a:rPr>
-                        <ns5:t> </ns5:t>
-                      </ns5:r>
-                      <ns5:r>
+                        <m:t> </m:t>
+                      </m:r>
+                      <m:r>
                         <a:rPr kumimoji="0" lang="en-US" sz="1800" b="0" i="1" u="none" strike="noStrike" kern="1200" cap="none" spc="0" normalizeH="0" baseline="0" noProof="0" smtClean="0">
                           <a:ln>
                             <a:noFill/>
@@ -7012,9 +6711,9 @@
                           <a:ea typeface="Cambria Math" panose="02040503050406030204" pitchFamily="18" charset="0"/>
                           <a:cs typeface="+mn-cs"/>
                         </a:rPr>
-                        <ns5:t>𝑟𝑎𝑑𝑖𝑎𝑙𝑙𝑦</ns5:t>
-                      </ns5:r>
-                      <ns5:r>
+                        <m:t>𝑟𝑎𝑑𝑖𝑎𝑙𝑙𝑦</m:t>
+                      </m:r>
+                      <m:r>
                         <a:rPr kumimoji="0" lang="en-US" sz="1800" b="0" i="1" u="none" strike="noStrike" kern="1200" cap="none" spc="0" normalizeH="0" baseline="0" noProof="0" smtClean="0">
                           <a:ln>
                             <a:noFill/>
@@ -7029,9 +6728,9 @@
                           <a:ea typeface="Cambria Math" panose="02040503050406030204" pitchFamily="18" charset="0"/>
                           <a:cs typeface="+mn-cs"/>
                         </a:rPr>
-                        <ns5:t> </ns5:t>
-                      </ns5:r>
-                      <ns5:r>
+                        <m:t> </m:t>
+                      </m:r>
+                      <m:r>
                         <a:rPr kumimoji="0" lang="en-US" sz="1800" b="0" i="1" u="none" strike="noStrike" kern="1200" cap="none" spc="0" normalizeH="0" baseline="0" noProof="0" smtClean="0">
                           <a:ln>
                             <a:noFill/>
@@ -7046,9 +6745,9 @@
                           <a:ea typeface="Cambria Math" panose="02040503050406030204" pitchFamily="18" charset="0"/>
                           <a:cs typeface="+mn-cs"/>
                         </a:rPr>
-                        <ns5:t>𝑓𝑟𝑜𝑚</ns5:t>
-                      </ns5:r>
-                      <ns5:r>
+                        <m:t>𝑓𝑟𝑜𝑚</m:t>
+                      </m:r>
+                      <m:r>
                         <a:rPr kumimoji="0" lang="en-US" sz="1800" b="0" i="1" u="none" strike="noStrike" kern="1200" cap="none" spc="0" normalizeH="0" baseline="0" noProof="0" smtClean="0">
                           <a:ln>
                             <a:noFill/>
@@ -7063,9 +6762,9 @@
                           <a:ea typeface="Cambria Math" panose="02040503050406030204" pitchFamily="18" charset="0"/>
                           <a:cs typeface="+mn-cs"/>
                         </a:rPr>
-                        <ns5:t> </ns5:t>
-                      </ns5:r>
-                      <ns5:r>
+                        <m:t> </m:t>
+                      </m:r>
+                      <m:r>
                         <a:rPr kumimoji="0" lang="en-US" sz="1800" b="0" i="1" u="none" strike="noStrike" kern="1200" cap="none" spc="0" normalizeH="0" baseline="0" noProof="0" smtClean="0">
                           <a:ln>
                             <a:noFill/>
@@ -7080,9 +6779,9 @@
                           <a:ea typeface="Cambria Math" panose="02040503050406030204" pitchFamily="18" charset="0"/>
                           <a:cs typeface="+mn-cs"/>
                         </a:rPr>
-                        <ns5:t>𝑒𝑚𝑖𝑠𝑠𝑖𝑜𝑛</ns5:t>
-                      </ns5:r>
-                      <ns5:r>
+                        <m:t>𝑒𝑚𝑖𝑠𝑠𝑖𝑜𝑛</m:t>
+                      </m:r>
+                      <m:r>
                         <a:rPr kumimoji="0" lang="en-US" sz="1800" b="0" i="1" u="none" strike="noStrike" kern="1200" cap="none" spc="0" normalizeH="0" baseline="0" noProof="0" smtClean="0">
                           <a:ln>
                             <a:noFill/>
@@ -7097,9 +6796,9 @@
                           <a:ea typeface="Cambria Math" panose="02040503050406030204" pitchFamily="18" charset="0"/>
                           <a:cs typeface="+mn-cs"/>
                         </a:rPr>
-                        <ns5:t> </ns5:t>
-                      </ns5:r>
-                      <ns5:r>
+                        <m:t> </m:t>
+                      </m:r>
+                      <m:r>
                         <a:rPr kumimoji="0" lang="en-US" sz="1800" b="0" i="1" u="none" strike="noStrike" kern="1200" cap="none" spc="0" normalizeH="0" baseline="0" noProof="0">
                           <a:ln>
                             <a:noFill/>
@@ -7114,9 +6813,9 @@
                           <a:ea typeface="Cambria Math" panose="02040503050406030204" pitchFamily="18" charset="0"/>
                           <a:cs typeface="+mn-cs"/>
                         </a:rPr>
-                        <ns5:t>𝑎𝑡</ns5:t>
-                      </ns5:r>
-                      <ns5:r>
+                        <m:t>𝑎𝑡</m:t>
+                      </m:r>
+                      <m:r>
                         <a:rPr kumimoji="0" lang="en-US" sz="1800" b="0" i="1" u="none" strike="noStrike" kern="1200" cap="none" spc="0" normalizeH="0" baseline="0" noProof="0">
                           <a:ln>
                             <a:noFill/>
@@ -7131,9 +6830,9 @@
                           <a:ea typeface="Cambria Math" panose="02040503050406030204" pitchFamily="18" charset="0"/>
                           <a:cs typeface="+mn-cs"/>
                         </a:rPr>
-                        <ns5:t> </ns5:t>
-                      </ns5:r>
-                      <ns5:r>
+                        <m:t> </m:t>
+                      </m:r>
+                      <m:r>
                         <a:rPr kumimoji="0" lang="en-US" sz="1800" b="0" i="1" u="none" strike="noStrike" kern="1200" cap="none" spc="0" normalizeH="0" baseline="0" noProof="0" smtClean="0">
                           <a:ln>
                             <a:noFill/>
@@ -7148,9 +6847,9 @@
                           <a:ea typeface="Cambria Math" panose="02040503050406030204" pitchFamily="18" charset="0"/>
                           <a:cs typeface="+mn-cs"/>
                         </a:rPr>
-                        <ns5:t>𝑠𝑝𝑒𝑒𝑑</ns5:t>
-                      </ns5:r>
-                      <ns5:r>
+                        <m:t>𝑠𝑝𝑒𝑒𝑑</m:t>
+                      </m:r>
+                      <m:r>
                         <a:rPr kumimoji="0" lang="en-US" sz="1800" b="0" i="1" u="none" strike="noStrike" kern="1200" cap="none" spc="0" normalizeH="0" baseline="0" noProof="0" smtClean="0">
                           <a:ln>
                             <a:noFill/>
@@ -7165,9 +6864,9 @@
                           <a:ea typeface="Cambria Math" panose="02040503050406030204" pitchFamily="18" charset="0"/>
                           <a:cs typeface="+mn-cs"/>
                         </a:rPr>
-                        <ns5:t> </ns5:t>
-                      </ns5:r>
-                      <ns5:r>
+                        <m:t> </m:t>
+                      </m:r>
+                      <m:r>
                         <a:rPr kumimoji="0" lang="en-US" sz="1800" b="1" i="1" u="none" strike="noStrike" kern="1200" cap="none" spc="0" normalizeH="0" baseline="0" noProof="0">
                           <a:ln>
                             <a:noFill/>
@@ -7182,9 +6881,9 @@
                           <a:ea typeface="Cambria Math" panose="02040503050406030204" pitchFamily="18" charset="0"/>
                           <a:cs typeface="+mn-cs"/>
                         </a:rPr>
-                        <ns5:t>@</ns5:t>
-                      </ns5:r>
-                      <ns5:r>
+                        <m:t>@</m:t>
+                      </m:r>
+                      <m:r>
                         <a:rPr kumimoji="0" lang="en-US" sz="1800" b="0" i="1" u="none" strike="noStrike" kern="1200" cap="none" spc="0" normalizeH="0" baseline="0" noProof="0">
                           <a:ln>
                             <a:noFill/>
@@ -7199,11 +6898,11 @@
                           <a:ea typeface="Cambria Math" panose="02040503050406030204" pitchFamily="18" charset="0"/>
                           <a:cs typeface="+mn-cs"/>
                         </a:rPr>
-                        <ns5:t>.</ns5:t>
-                      </ns5:r>
-                    </ns5:oMath>
-                  </ns5:oMathPara>
-                </ns4:m>
+                        <m:t>.</m:t>
+                      </m:r>
+                    </m:oMath>
+                  </m:oMathPara>
+                </a14:m>
                 <a:endParaRPr kumimoji="0" lang="en-US" sz="1800" b="0" i="1" u="none" strike="noStrike" kern="1200" cap="none" spc="0" normalizeH="0" baseline="0" noProof="0" dirty="0">
                   <a:ln>
                     <a:noFill/>
@@ -7237,13 +6936,13 @@
                   <a:tabLst/>
                   <a:defRPr/>
                 </a:pPr>
-                <ns4:m>
-                  <ns5:oMathPara>
-                    <ns5:oMathParaPr>
-                      <ns5:jc ns5:val="centerGroup"/>
-                    </ns5:oMathParaPr>
-                    <ns5:oMath>
-                      <ns5:r>
+                <a14:m>
+                  <m:oMathPara>
+                    <m:oMathParaPr>
+                      <m:jc m:val="centerGroup"/>
+                    </m:oMathParaPr>
+                    <m:oMath>
+                      <m:r>
                         <a:rPr kumimoji="0" lang="en-US" sz="1800" b="0" i="1" u="none" strike="noStrike" kern="1200" cap="none" spc="0" normalizeH="0" baseline="0" noProof="0" smtClean="0">
                           <a:ln>
                             <a:noFill/>
@@ -7258,9 +6957,9 @@
                           <a:ea typeface="Cambria Math" panose="02040503050406030204" pitchFamily="18" charset="0"/>
                           <a:cs typeface="+mn-cs"/>
                         </a:rPr>
-                        <ns5:t>𝑃h𝑜𝑡𝑜𝑛</ns5:t>
-                      </ns5:r>
-                      <ns5:r>
+                        <m:t>𝑃h𝑜𝑡𝑜𝑛</m:t>
+                      </m:r>
+                      <m:r>
                         <a:rPr kumimoji="0" lang="en-US" sz="1800" b="0" i="1" u="none" strike="noStrike" kern="1200" cap="none" spc="0" normalizeH="0" baseline="0" noProof="0" smtClean="0">
                           <a:ln>
                             <a:noFill/>
@@ -7275,9 +6974,9 @@
                           <a:ea typeface="Cambria Math" panose="02040503050406030204" pitchFamily="18" charset="0"/>
                           <a:cs typeface="+mn-cs"/>
                         </a:rPr>
-                        <ns5:t> </ns5:t>
-                      </ns5:r>
-                      <ns5:r>
+                        <m:t> </m:t>
+                      </m:r>
+                      <m:r>
                         <a:rPr kumimoji="0" lang="en-US" sz="1800" b="0" i="1" u="none" strike="noStrike" kern="1200" cap="none" spc="0" normalizeH="0" baseline="0" noProof="0" smtClean="0">
                           <a:ln>
                             <a:noFill/>
@@ -7292,9 +6991,9 @@
                           <a:ea typeface="Cambria Math" panose="02040503050406030204" pitchFamily="18" charset="0"/>
                           <a:cs typeface="+mn-cs"/>
                         </a:rPr>
-                        <ns5:t>𝑠𝑡𝑟𝑢𝑐𝑡𝑢𝑟𝑒𝑠</ns5:t>
-                      </ns5:r>
-                      <ns5:r>
+                        <m:t>𝑠𝑡𝑟𝑢𝑐𝑡𝑢𝑟𝑒𝑠</m:t>
+                      </m:r>
+                      <m:r>
                         <a:rPr kumimoji="0" lang="en-US" sz="1800" b="0" i="1" u="none" strike="noStrike" kern="1200" cap="none" spc="0" normalizeH="0" baseline="0" noProof="0" smtClean="0">
                           <a:ln>
                             <a:noFill/>
@@ -7309,9 +7008,9 @@
                           <a:ea typeface="Cambria Math" panose="02040503050406030204" pitchFamily="18" charset="0"/>
                           <a:cs typeface="+mn-cs"/>
                         </a:rPr>
-                        <ns5:t> </ns5:t>
-                      </ns5:r>
-                      <ns5:r>
+                        <m:t> </m:t>
+                      </m:r>
+                      <m:r>
                         <a:rPr kumimoji="0" lang="en-US" sz="1800" b="0" i="1" u="none" strike="noStrike" kern="1200" cap="none" spc="0" normalizeH="0" baseline="0" noProof="0" smtClean="0">
                           <a:ln>
                             <a:noFill/>
@@ -7326,9 +7025,9 @@
                           <a:ea typeface="Cambria Math" panose="02040503050406030204" pitchFamily="18" charset="0"/>
                           <a:cs typeface="+mn-cs"/>
                         </a:rPr>
-                        <ns5:t>𝑡𝑟𝑎𝑣𝑒𝑙</ns5:t>
-                      </ns5:r>
-                      <ns5:r>
+                        <m:t>𝑡𝑟𝑎𝑣𝑒𝑙</m:t>
+                      </m:r>
+                      <m:r>
                         <a:rPr kumimoji="0" lang="en-US" sz="1800" b="0" i="1" u="none" strike="noStrike" kern="1200" cap="none" spc="0" normalizeH="0" baseline="0" noProof="0" smtClean="0">
                           <a:ln>
                             <a:noFill/>
@@ -7343,9 +7042,9 @@
                           <a:ea typeface="Cambria Math" panose="02040503050406030204" pitchFamily="18" charset="0"/>
                           <a:cs typeface="+mn-cs"/>
                         </a:rPr>
-                        <ns5:t> </ns5:t>
-                      </ns5:r>
-                      <ns5:r>
+                        <m:t> </m:t>
+                      </m:r>
+                      <m:r>
                         <a:rPr kumimoji="0" lang="en-US" sz="1800" b="0" i="1" u="none" strike="noStrike" kern="1200" cap="none" spc="0" normalizeH="0" baseline="0" noProof="0" smtClean="0">
                           <a:ln>
                             <a:noFill/>
@@ -7360,9 +7059,9 @@
                           <a:ea typeface="Cambria Math" panose="02040503050406030204" pitchFamily="18" charset="0"/>
                           <a:cs typeface="+mn-cs"/>
                         </a:rPr>
-                        <ns5:t>𝑎𝑡</ns5:t>
-                      </ns5:r>
-                      <ns5:r>
+                        <m:t>𝑎𝑡</m:t>
+                      </m:r>
+                      <m:r>
                         <a:rPr kumimoji="0" lang="en-US" sz="1800" b="0" i="1" u="none" strike="noStrike" kern="1200" cap="none" spc="0" normalizeH="0" baseline="0" noProof="0" smtClean="0">
                           <a:ln>
                             <a:noFill/>
@@ -7377,9 +7076,9 @@
                           <a:ea typeface="Cambria Math" panose="02040503050406030204" pitchFamily="18" charset="0"/>
                           <a:cs typeface="+mn-cs"/>
                         </a:rPr>
-                        <ns5:t> </ns5:t>
-                      </ns5:r>
-                      <ns5:r>
+                        <m:t> </m:t>
+                      </m:r>
+                      <m:r>
                         <a:rPr kumimoji="0" lang="en-US" sz="1800" b="0" i="1" u="none" strike="noStrike" kern="1200" cap="none" spc="0" normalizeH="0" baseline="0" noProof="0" smtClean="0">
                           <a:ln>
                             <a:noFill/>
@@ -7394,9 +7093,9 @@
                           <a:ea typeface="Cambria Math" panose="02040503050406030204" pitchFamily="18" charset="0"/>
                           <a:cs typeface="+mn-cs"/>
                         </a:rPr>
-                        <ns5:t>𝑐</ns5:t>
-                      </ns5:r>
-                      <ns5:r>
+                        <m:t>𝑐</m:t>
+                      </m:r>
+                      <m:r>
                         <a:rPr kumimoji="0" lang="en-US" sz="1800" b="0" i="1" u="none" strike="noStrike" kern="1200" cap="none" spc="0" normalizeH="0" baseline="0" noProof="0" smtClean="0">
                           <a:ln>
                             <a:noFill/>
@@ -7411,9 +7110,9 @@
                           <a:ea typeface="Cambria Math" panose="02040503050406030204" pitchFamily="18" charset="0"/>
                           <a:cs typeface="+mn-cs"/>
                         </a:rPr>
-                        <ns5:t>, </ns5:t>
-                      </ns5:r>
-                      <ns5:r>
+                        <m:t>, </m:t>
+                      </m:r>
+                      <m:r>
                         <a:rPr kumimoji="0" lang="en-US" sz="1800" b="0" i="1" u="none" strike="noStrike" kern="1200" cap="none" spc="0" normalizeH="0" baseline="0" noProof="0" smtClean="0">
                           <a:ln>
                             <a:noFill/>
@@ -7428,9 +7127,9 @@
                           <a:ea typeface="Cambria Math" panose="02040503050406030204" pitchFamily="18" charset="0"/>
                           <a:cs typeface="+mn-cs"/>
                         </a:rPr>
-                        <ns5:t>𝑡h𝑒</ns5:t>
-                      </ns5:r>
-                      <ns5:r>
+                        <m:t>𝑡h𝑒</m:t>
+                      </m:r>
+                      <m:r>
                         <a:rPr kumimoji="0" lang="en-US" sz="1800" b="0" i="1" u="none" strike="noStrike" kern="1200" cap="none" spc="0" normalizeH="0" baseline="0" noProof="0" smtClean="0">
                           <a:ln>
                             <a:noFill/>
@@ -7445,9 +7144,9 @@
                           <a:ea typeface="Cambria Math" panose="02040503050406030204" pitchFamily="18" charset="0"/>
                           <a:cs typeface="+mn-cs"/>
                         </a:rPr>
-                        <ns5:t> </ns5:t>
-                      </ns5:r>
-                      <ns5:r>
+                        <m:t> </m:t>
+                      </m:r>
+                      <m:r>
                         <a:rPr kumimoji="0" lang="en-US" sz="1800" b="1" i="1" u="none" strike="noStrike" kern="1200" cap="none" spc="0" normalizeH="0" baseline="0" noProof="0" smtClean="0">
                           <a:ln>
                             <a:noFill/>
@@ -7462,9 +7161,9 @@
                           <a:ea typeface="Cambria Math" panose="02040503050406030204" pitchFamily="18" charset="0"/>
                           <a:cs typeface="+mn-cs"/>
                         </a:rPr>
-                        <ns5:t>𝒍𝒐𝒄𝒂𝒍</ns5:t>
-                      </ns5:r>
-                      <ns5:r>
+                        <m:t>𝒍𝒐𝒄𝒂𝒍</m:t>
+                      </m:r>
+                      <m:r>
                         <a:rPr kumimoji="0" lang="en-US" sz="1800" b="0" i="1" u="none" strike="noStrike" kern="1200" cap="none" spc="0" normalizeH="0" baseline="0" noProof="0" smtClean="0">
                           <a:ln>
                             <a:noFill/>
@@ -7479,9 +7178,9 @@
                           <a:ea typeface="Cambria Math" panose="02040503050406030204" pitchFamily="18" charset="0"/>
                           <a:cs typeface="+mn-cs"/>
                         </a:rPr>
-                        <ns5:t> </ns5:t>
-                      </ns5:r>
-                      <ns5:r>
+                        <m:t> </m:t>
+                      </m:r>
+                      <m:r>
                         <a:rPr kumimoji="0" lang="en-US" sz="1800" b="0" i="1" u="none" strike="noStrike" kern="1200" cap="none" spc="0" normalizeH="0" baseline="0" noProof="0" smtClean="0">
                           <a:ln>
                             <a:noFill/>
@@ -7496,9 +7195,9 @@
                           <a:ea typeface="Cambria Math" panose="02040503050406030204" pitchFamily="18" charset="0"/>
                           <a:cs typeface="+mn-cs"/>
                         </a:rPr>
-                        <ns5:t>𝑠𝑝𝑒𝑒𝑑</ns5:t>
-                      </ns5:r>
-                      <ns5:r>
+                        <m:t>𝑠𝑝𝑒𝑒𝑑</m:t>
+                      </m:r>
+                      <m:r>
                         <a:rPr kumimoji="0" lang="en-US" sz="1800" b="0" i="1" u="none" strike="noStrike" kern="1200" cap="none" spc="0" normalizeH="0" baseline="0" noProof="0" smtClean="0">
                           <a:ln>
                             <a:noFill/>
@@ -7513,9 +7212,9 @@
                           <a:ea typeface="Cambria Math" panose="02040503050406030204" pitchFamily="18" charset="0"/>
                           <a:cs typeface="+mn-cs"/>
                         </a:rPr>
-                        <ns5:t> </ns5:t>
-                      </ns5:r>
-                      <ns5:r>
+                        <m:t> </m:t>
+                      </m:r>
+                      <m:r>
                         <a:rPr kumimoji="0" lang="en-US" sz="1800" b="0" i="1" u="none" strike="noStrike" kern="1200" cap="none" spc="0" normalizeH="0" baseline="0" noProof="0" smtClean="0">
                           <a:ln>
                             <a:noFill/>
@@ -7530,9 +7229,9 @@
                           <a:ea typeface="Cambria Math" panose="02040503050406030204" pitchFamily="18" charset="0"/>
                           <a:cs typeface="+mn-cs"/>
                         </a:rPr>
-                        <ns5:t>𝑜𝑓</ns5:t>
-                      </ns5:r>
-                      <ns5:r>
+                        <m:t>𝑜𝑓</m:t>
+                      </m:r>
+                      <m:r>
                         <a:rPr kumimoji="0" lang="en-US" sz="1800" b="0" i="1" u="none" strike="noStrike" kern="1200" cap="none" spc="0" normalizeH="0" baseline="0" noProof="0" smtClean="0">
                           <a:ln>
                             <a:noFill/>
@@ -7547,9 +7246,9 @@
                           <a:ea typeface="Cambria Math" panose="02040503050406030204" pitchFamily="18" charset="0"/>
                           <a:cs typeface="+mn-cs"/>
                         </a:rPr>
-                        <ns5:t> </ns5:t>
-                      </ns5:r>
-                      <ns5:r>
+                        <m:t> </m:t>
+                      </m:r>
+                      <m:r>
                         <a:rPr kumimoji="0" lang="en-US" sz="1800" b="0" i="1" u="none" strike="noStrike" kern="1200" cap="none" spc="0" normalizeH="0" baseline="0" noProof="0" smtClean="0">
                           <a:ln>
                             <a:noFill/>
@@ -7564,9 +7263,9 @@
                           <a:ea typeface="Cambria Math" panose="02040503050406030204" pitchFamily="18" charset="0"/>
                           <a:cs typeface="+mn-cs"/>
                         </a:rPr>
-                        <ns5:t>𝑙𝑖𝑔h𝑡</ns5:t>
-                      </ns5:r>
-                      <ns5:r>
+                        <m:t>𝑙𝑖𝑔h𝑡</m:t>
+                      </m:r>
+                      <m:r>
                         <a:rPr kumimoji="0" lang="en-US" sz="1800" b="0" i="1" u="none" strike="noStrike" kern="1200" cap="none" spc="0" normalizeH="0" baseline="0" noProof="0" smtClean="0">
                           <a:ln>
                             <a:noFill/>
@@ -7581,9 +7280,9 @@
                           <a:ea typeface="Cambria Math" panose="02040503050406030204" pitchFamily="18" charset="0"/>
                           <a:cs typeface="+mn-cs"/>
                         </a:rPr>
-                        <ns5:t> </ns5:t>
-                      </ns5:r>
-                      <ns5:r>
+                        <m:t> </m:t>
+                      </m:r>
+                      <m:r>
                         <a:rPr kumimoji="0" lang="en-US" sz="1800" b="0" i="1" u="none" strike="noStrike" kern="1200" cap="none" spc="0" normalizeH="0" baseline="0" noProof="0" smtClean="0">
                           <a:ln>
                             <a:noFill/>
@@ -7598,9 +7297,9 @@
                           <a:ea typeface="Cambria Math" panose="02040503050406030204" pitchFamily="18" charset="0"/>
                           <a:cs typeface="+mn-cs"/>
                         </a:rPr>
-                        <ns5:t>𝑡h𝑟𝑜𝑢𝑔h</ns5:t>
-                      </ns5:r>
-                      <ns5:r>
+                        <m:t>𝑡h𝑟𝑜𝑢𝑔h</m:t>
+                      </m:r>
+                      <m:r>
                         <a:rPr kumimoji="0" lang="en-US" sz="1800" b="0" i="1" u="none" strike="noStrike" kern="1200" cap="none" spc="0" normalizeH="0" baseline="0" noProof="0" smtClean="0">
                           <a:ln>
                             <a:noFill/>
@@ -7615,9 +7314,9 @@
                           <a:ea typeface="Cambria Math" panose="02040503050406030204" pitchFamily="18" charset="0"/>
                           <a:cs typeface="+mn-cs"/>
                         </a:rPr>
-                        <ns5:t> </ns5:t>
-                      </ns5:r>
-                      <ns5:r>
+                        <m:t> </m:t>
+                      </m:r>
+                      <m:r>
                         <a:rPr kumimoji="0" lang="en-US" sz="1800" b="0" i="1" u="none" strike="noStrike" kern="1200" cap="none" spc="0" normalizeH="0" baseline="0" noProof="0" smtClean="0">
                           <a:ln>
                             <a:noFill/>
@@ -7632,9 +7331,9 @@
                           <a:ea typeface="Cambria Math" panose="02040503050406030204" pitchFamily="18" charset="0"/>
                           <a:cs typeface="+mn-cs"/>
                         </a:rPr>
-                        <ns5:t>𝑡h𝑒</ns5:t>
-                      </ns5:r>
-                      <ns5:r>
+                        <m:t>𝑡h𝑒</m:t>
+                      </m:r>
+                      <m:r>
                         <a:rPr kumimoji="0" lang="en-US" sz="1800" b="0" i="1" u="none" strike="noStrike" kern="1200" cap="none" spc="0" normalizeH="0" baseline="0" noProof="0" smtClean="0">
                           <a:ln>
                             <a:noFill/>
@@ -7649,9 +7348,9 @@
                           <a:ea typeface="Cambria Math" panose="02040503050406030204" pitchFamily="18" charset="0"/>
                           <a:cs typeface="+mn-cs"/>
                         </a:rPr>
-                        <ns5:t> </ns5:t>
-                      </ns5:r>
-                      <ns5:r>
+                        <m:t> </m:t>
+                      </m:r>
+                      <m:r>
                         <a:rPr kumimoji="0" lang="en-US" sz="1800" b="0" i="1" u="none" strike="noStrike" kern="1200" cap="none" spc="0" normalizeH="0" baseline="0" noProof="0" smtClean="0">
                           <a:ln>
                             <a:noFill/>
@@ -7666,9 +7365,9 @@
                           <a:ea typeface="Cambria Math" panose="02040503050406030204" pitchFamily="18" charset="0"/>
                           <a:cs typeface="+mn-cs"/>
                         </a:rPr>
-                        <ns5:t>𝑎𝑒𝑡h𝑒𝑟</ns5:t>
-                      </ns5:r>
-                      <ns5:r>
+                        <m:t>𝑎𝑒𝑡h𝑒𝑟</m:t>
+                      </m:r>
+                      <m:r>
                         <a:rPr kumimoji="0" lang="en-US" sz="1800" b="0" i="1" u="none" strike="noStrike" kern="1200" cap="none" spc="0" normalizeH="0" baseline="0" noProof="0" smtClean="0">
                           <a:ln>
                             <a:noFill/>
@@ -7683,11 +7382,11 @@
                           <a:ea typeface="Cambria Math" panose="02040503050406030204" pitchFamily="18" charset="0"/>
                           <a:cs typeface="+mn-cs"/>
                         </a:rPr>
-                        <ns5:t>.</ns5:t>
-                      </ns5:r>
-                    </ns5:oMath>
-                  </ns5:oMathPara>
-                </ns4:m>
+                        <m:t>.</m:t>
+                      </m:r>
+                    </m:oMath>
+                  </m:oMathPara>
+                </a14:m>
                 <a:endParaRPr kumimoji="0" lang="en-US" sz="1800" b="0" i="1" u="none" strike="noStrike" kern="1200" cap="none" spc="0" normalizeH="0" baseline="0" noProof="0" dirty="0">
                   <a:ln>
                     <a:noFill/>
@@ -7721,13 +7420,13 @@
                   <a:tabLst/>
                   <a:defRPr/>
                 </a:pPr>
-                <ns4:m>
-                  <ns5:oMathPara>
-                    <ns5:oMathParaPr>
-                      <ns5:jc ns5:val="centerGroup"/>
-                    </ns5:oMathParaPr>
-                    <ns5:oMath>
-                      <ns5:r>
+                <a14:m>
+                  <m:oMathPara>
+                    <m:oMathParaPr>
+                      <m:jc m:val="centerGroup"/>
+                    </m:oMathParaPr>
+                    <m:oMath>
+                      <m:r>
                         <a:rPr kumimoji="0" lang="en-US" sz="1800" b="0" i="1" u="none" strike="noStrike" kern="1200" cap="none" spc="0" normalizeH="0" baseline="0" noProof="0" smtClean="0">
                           <a:ln>
                             <a:noFill/>
@@ -7742,9 +7441,9 @@
                           <a:ea typeface="Cambria Math" panose="02040503050406030204" pitchFamily="18" charset="0"/>
                           <a:cs typeface="+mn-cs"/>
                         </a:rPr>
-                        <ns5:t>𝐿𝑜𝑐𝑎𝑙</ns5:t>
-                      </ns5:r>
-                      <ns5:r>
+                        <m:t>𝐿𝑜𝑐𝑎𝑙</m:t>
+                      </m:r>
+                      <m:r>
                         <a:rPr kumimoji="0" lang="en-US" sz="1800" b="0" i="1" u="none" strike="noStrike" kern="1200" cap="none" spc="0" normalizeH="0" baseline="0" noProof="0" smtClean="0">
                           <a:ln>
                             <a:noFill/>
@@ -7759,9 +7458,9 @@
                           <a:ea typeface="Cambria Math" panose="02040503050406030204" pitchFamily="18" charset="0"/>
                           <a:cs typeface="+mn-cs"/>
                         </a:rPr>
-                        <ns5:t> </ns5:t>
-                      </ns5:r>
-                      <ns5:r>
+                        <m:t> </m:t>
+                      </m:r>
+                      <m:r>
                         <a:rPr kumimoji="0" lang="en-US" sz="1800" b="0" i="1" u="none" strike="noStrike" kern="1200" cap="none" spc="0" normalizeH="0" baseline="0" noProof="0" smtClean="0">
                           <a:ln>
                             <a:noFill/>
@@ -7776,9 +7475,9 @@
                           <a:ea typeface="Cambria Math" panose="02040503050406030204" pitchFamily="18" charset="0"/>
                           <a:cs typeface="+mn-cs"/>
                         </a:rPr>
-                        <ns5:t>𝑐</ns5:t>
-                      </ns5:r>
-                      <ns5:r>
+                        <m:t>𝑐</m:t>
+                      </m:r>
+                      <m:r>
                         <a:rPr kumimoji="0" lang="en-US" sz="1800" b="0" i="1" u="none" strike="noStrike" kern="1200" cap="none" spc="0" normalizeH="0" baseline="0" noProof="0" smtClean="0">
                           <a:ln>
                             <a:noFill/>
@@ -7793,9 +7492,9 @@
                           <a:ea typeface="Cambria Math" panose="02040503050406030204" pitchFamily="18" charset="0"/>
                           <a:cs typeface="+mn-cs"/>
                         </a:rPr>
-                        <ns5:t> </ns5:t>
-                      </ns5:r>
-                      <ns5:r>
+                        <m:t> </m:t>
+                      </m:r>
+                      <m:r>
                         <a:rPr kumimoji="0" lang="en-US" sz="1800" b="0" i="1" u="none" strike="noStrike" kern="1200" cap="none" spc="0" normalizeH="0" baseline="0" noProof="0" smtClean="0">
                           <a:ln>
                             <a:noFill/>
@@ -7810,9 +7509,9 @@
                           <a:ea typeface="Cambria Math" panose="02040503050406030204" pitchFamily="18" charset="0"/>
                           <a:cs typeface="+mn-cs"/>
                         </a:rPr>
-                        <ns5:t>𝑎𝑝𝑝𝑟𝑜𝑎𝑐h𝑒𝑠</ns5:t>
-                      </ns5:r>
-                      <ns5:r>
+                        <m:t>𝑎𝑝𝑝𝑟𝑜𝑎𝑐h𝑒𝑠</m:t>
+                      </m:r>
+                      <m:r>
                         <a:rPr kumimoji="0" lang="en-US" sz="1800" b="0" i="1" u="none" strike="noStrike" kern="1200" cap="none" spc="0" normalizeH="0" baseline="0" noProof="0" smtClean="0">
                           <a:ln>
                             <a:noFill/>
@@ -7827,9 +7526,9 @@
                           <a:ea typeface="Cambria Math" panose="02040503050406030204" pitchFamily="18" charset="0"/>
                           <a:cs typeface="+mn-cs"/>
                         </a:rPr>
-                        <ns5:t> </ns5:t>
-                      </ns5:r>
-                      <ns5:r>
+                        <m:t> </m:t>
+                      </m:r>
+                      <m:r>
                         <a:rPr kumimoji="0" lang="en-US" sz="1800" b="1" i="1" u="none" strike="noStrike" kern="1200" cap="none" spc="0" normalizeH="0" baseline="0" noProof="0" smtClean="0">
                           <a:ln>
                             <a:noFill/>
@@ -7844,9 +7543,9 @@
                           <a:ea typeface="Cambria Math" panose="02040503050406030204" pitchFamily="18" charset="0"/>
                           <a:cs typeface="+mn-cs"/>
                         </a:rPr>
-                        <ns5:t>@</ns5:t>
-                      </ns5:r>
-                      <ns5:r>
+                        <m:t>@</m:t>
+                      </m:r>
+                      <m:r>
                         <a:rPr kumimoji="0" lang="en-US" sz="1800" b="0" i="1" u="none" strike="noStrike" kern="1200" cap="none" spc="0" normalizeH="0" baseline="0" noProof="0" smtClean="0">
                           <a:ln>
                             <a:noFill/>
@@ -7861,9 +7560,9 @@
                           <a:ea typeface="Cambria Math" panose="02040503050406030204" pitchFamily="18" charset="0"/>
                           <a:cs typeface="+mn-cs"/>
                         </a:rPr>
-                        <ns5:t> </ns5:t>
-                      </ns5:r>
-                      <ns5:r>
+                        <m:t> </m:t>
+                      </m:r>
+                      <m:r>
                         <a:rPr kumimoji="0" lang="en-US" sz="1800" b="0" i="1" u="none" strike="noStrike" kern="1200" cap="none" spc="0" normalizeH="0" baseline="0" noProof="0" smtClean="0">
                           <a:ln>
                             <a:noFill/>
@@ -7878,11 +7577,11 @@
                           <a:ea typeface="Cambria Math" panose="02040503050406030204" pitchFamily="18" charset="0"/>
                           <a:cs typeface="+mn-cs"/>
                         </a:rPr>
-                        <ns5:t>𝑎𝑠</ns5:t>
-                      </ns5:r>
-                      <ns5:sSub>
-                        <ns5:sSubPr>
-                          <ns5:ctrlPr>
+                        <m:t>𝑎𝑠</m:t>
+                      </m:r>
+                      <m:sSub>
+                        <m:sSubPr>
+                          <m:ctrlPr>
                             <a:rPr kumimoji="0" lang="en-US" sz="1800" b="0" i="1" u="none" strike="noStrike" kern="1200" cap="none" spc="0" normalizeH="0" baseline="0" noProof="0">
                               <a:ln>
                                 <a:noFill/>
@@ -7897,10 +7596,10 @@
                               <a:ea typeface="Cambria Math" panose="02040503050406030204" pitchFamily="18" charset="0"/>
                               <a:cs typeface="+mn-cs"/>
                             </a:rPr>
-                          </ns5:ctrlPr>
-                        </ns5:sSubPr>
-                        <ns5:e>
-                          <ns5:r>
+                          </m:ctrlPr>
+                        </m:sSubPr>
+                        <m:e>
+                          <m:r>
                             <a:rPr kumimoji="0" lang="en-US" sz="1800" b="0" i="1" u="none" strike="noStrike" kern="1200" cap="none" spc="0" normalizeH="0" baseline="0" noProof="0" smtClean="0">
                               <a:ln>
                                 <a:noFill/>
@@ -7915,9 +7614,9 @@
                               <a:ea typeface="Cambria Math" panose="02040503050406030204" pitchFamily="18" charset="0"/>
                               <a:cs typeface="+mn-cs"/>
                             </a:rPr>
-                            <ns5:t> </ns5:t>
-                          </ns5:r>
-                          <ns5:r>
+                            <m:t> </m:t>
+                          </m:r>
+                          <m:r>
                             <a:rPr kumimoji="0" lang="en-US" sz="1800" b="0" i="1" u="none" strike="noStrike" kern="1200" cap="none" spc="0" normalizeH="0" baseline="0" noProof="0">
                               <a:ln>
                                 <a:noFill/>
@@ -7932,11 +7631,11 @@
                               <a:ea typeface="Cambria Math" panose="02040503050406030204" pitchFamily="18" charset="0"/>
                               <a:cs typeface="+mn-cs"/>
                             </a:rPr>
-                            <ns5:t>𝐸𝑛𝑒𝑟𝑔𝑦</ns5:t>
-                          </ns5:r>
-                        </ns5:e>
-                        <ns5:sub>
-                          <ns5:r>
+                            <m:t>𝐸𝑛𝑒𝑟𝑔𝑦</m:t>
+                          </m:r>
+                        </m:e>
+                        <m:sub>
+                          <m:r>
                             <a:rPr kumimoji="0" lang="en-US" sz="1800" b="0" i="1" u="none" strike="noStrike" kern="1200" cap="none" spc="0" normalizeH="0" baseline="0" noProof="0">
                               <a:ln>
                                 <a:noFill/>
@@ -7951,11 +7650,11 @@
                               <a:ea typeface="Cambria Math" panose="02040503050406030204" pitchFamily="18" charset="0"/>
                               <a:cs typeface="+mn-cs"/>
                             </a:rPr>
-                            <ns5:t>𝐴𝑃𝑃𝐴𝑅𝐸𝑁𝑇</ns5:t>
-                          </ns5:r>
-                        </ns5:sub>
-                      </ns5:sSub>
-                      <ns5:r>
+                            <m:t>𝐴𝑃𝑃𝐴𝑅𝐸𝑁𝑇</m:t>
+                          </m:r>
+                        </m:sub>
+                      </m:sSub>
+                      <m:r>
                         <a:rPr kumimoji="0" lang="en-US" sz="1800" b="0" i="1" u="none" strike="noStrike" kern="1200" cap="none" spc="0" normalizeH="0" baseline="0" noProof="0" smtClean="0">
                           <a:ln>
                             <a:noFill/>
@@ -7970,9 +7669,9 @@
                           <a:ea typeface="Cambria Math" panose="02040503050406030204" pitchFamily="18" charset="0"/>
                           <a:cs typeface="+mn-cs"/>
                         </a:rPr>
-                        <ns5:t> </ns5:t>
-                      </ns5:r>
-                      <ns5:r>
+                        <m:t> </m:t>
+                      </m:r>
+                      <m:r>
                         <a:rPr kumimoji="0" lang="en-US" sz="1800" b="0" i="1" u="none" strike="noStrike" kern="1200" cap="none" spc="0" normalizeH="0" baseline="0" noProof="0" smtClean="0">
                           <a:ln>
                             <a:noFill/>
@@ -7987,9 +7686,9 @@
                           <a:ea typeface="Cambria Math" panose="02040503050406030204" pitchFamily="18" charset="0"/>
                           <a:cs typeface="+mn-cs"/>
                         </a:rPr>
-                        <ns5:t>𝑜𝑓</ns5:t>
-                      </ns5:r>
-                      <ns5:r>
+                        <m:t>𝑜𝑓</m:t>
+                      </m:r>
+                      <m:r>
                         <a:rPr kumimoji="0" lang="en-US" sz="1800" b="0" i="1" u="none" strike="noStrike" kern="1200" cap="none" spc="0" normalizeH="0" baseline="0" noProof="0" smtClean="0">
                           <a:ln>
                             <a:noFill/>
@@ -8004,9 +7703,9 @@
                           <a:ea typeface="Cambria Math" panose="02040503050406030204" pitchFamily="18" charset="0"/>
                           <a:cs typeface="+mn-cs"/>
                         </a:rPr>
-                        <ns5:t> </ns5:t>
-                      </ns5:r>
-                      <ns5:r>
+                        <m:t> </m:t>
+                      </m:r>
+                      <m:r>
                         <a:rPr kumimoji="0" lang="en-US" sz="1800" b="0" i="1" u="none" strike="noStrike" kern="1200" cap="none" spc="0" normalizeH="0" baseline="0" noProof="0" smtClean="0">
                           <a:ln>
                             <a:noFill/>
@@ -8021,9 +7720,9 @@
                           <a:ea typeface="Cambria Math" panose="02040503050406030204" pitchFamily="18" charset="0"/>
                           <a:cs typeface="+mn-cs"/>
                         </a:rPr>
-                        <ns5:t>𝑡h𝑒</ns5:t>
-                      </ns5:r>
-                      <ns5:r>
+                        <m:t>𝑡h𝑒</m:t>
+                      </m:r>
+                      <m:r>
                         <a:rPr kumimoji="0" lang="en-US" sz="1800" b="0" i="1" u="none" strike="noStrike" kern="1200" cap="none" spc="0" normalizeH="0" baseline="0" noProof="0" smtClean="0">
                           <a:ln>
                             <a:noFill/>
@@ -8038,9 +7737,9 @@
                           <a:ea typeface="Cambria Math" panose="02040503050406030204" pitchFamily="18" charset="0"/>
                           <a:cs typeface="+mn-cs"/>
                         </a:rPr>
-                        <ns5:t> </ns5:t>
-                      </ns5:r>
-                      <ns5:r>
+                        <m:t> </m:t>
+                      </m:r>
+                      <m:r>
                         <a:rPr kumimoji="0" lang="en-US" sz="1800" b="0" i="1" u="none" strike="noStrike" kern="1200" cap="none" spc="0" normalizeH="0" baseline="0" noProof="0" smtClean="0">
                           <a:ln>
                             <a:noFill/>
@@ -8055,9 +7754,9 @@
                           <a:ea typeface="Cambria Math" panose="02040503050406030204" pitchFamily="18" charset="0"/>
                           <a:cs typeface="+mn-cs"/>
                         </a:rPr>
-                        <ns5:t>𝑎𝑒𝑡h𝑒𝑟</ns5:t>
-                      </ns5:r>
-                      <ns5:r>
+                        <m:t>𝑎𝑒𝑡h𝑒𝑟</m:t>
+                      </m:r>
+                      <m:r>
                         <a:rPr kumimoji="0" lang="en-US" sz="1800" b="0" i="1" u="none" strike="noStrike" kern="1200" cap="none" spc="0" normalizeH="0" baseline="0" noProof="0" smtClean="0">
                           <a:ln>
                             <a:noFill/>
@@ -8072,9 +7771,9 @@
                           <a:ea typeface="Cambria Math" panose="02040503050406030204" pitchFamily="18" charset="0"/>
                           <a:cs typeface="+mn-cs"/>
                         </a:rPr>
-                        <ns5:t> </ns5:t>
-                      </ns5:r>
-                      <ns5:r>
+                        <m:t> </m:t>
+                      </m:r>
+                      <m:r>
                         <a:rPr kumimoji="0" lang="en-US" sz="1800" b="0" i="1" u="none" strike="noStrike" kern="1200" cap="none" spc="0" normalizeH="0" baseline="0" noProof="0" smtClean="0">
                           <a:ln>
                             <a:noFill/>
@@ -8089,9 +7788,9 @@
                           <a:ea typeface="Cambria Math" panose="02040503050406030204" pitchFamily="18" charset="0"/>
                           <a:cs typeface="+mn-cs"/>
                         </a:rPr>
-                        <ns5:t>𝑎𝑝𝑝𝑟𝑜𝑎𝑐h𝑒𝑠</ns5:t>
-                      </ns5:r>
-                      <ns5:r>
+                        <m:t>𝑎𝑝𝑝𝑟𝑜𝑎𝑐h𝑒𝑠</m:t>
+                      </m:r>
+                      <m:r>
                         <a:rPr kumimoji="0" lang="en-US" sz="1800" b="0" i="1" u="none" strike="noStrike" kern="1200" cap="none" spc="0" normalizeH="0" baseline="0" noProof="0" smtClean="0">
                           <a:ln>
                             <a:noFill/>
@@ -8106,9 +7805,9 @@
                           <a:ea typeface="Cambria Math" panose="02040503050406030204" pitchFamily="18" charset="0"/>
                           <a:cs typeface="+mn-cs"/>
                         </a:rPr>
-                        <ns5:t> </ns5:t>
-                      </ns5:r>
-                      <ns5:r>
+                        <m:t> </m:t>
+                      </m:r>
+                      <m:r>
                         <a:rPr kumimoji="0" lang="en-US" sz="1800" b="0" i="1" u="none" strike="noStrike" kern="1200" cap="none" spc="0" normalizeH="0" baseline="0" noProof="0" smtClean="0">
                           <a:ln>
                             <a:noFill/>
@@ -8123,9 +7822,9 @@
                           <a:ea typeface="Cambria Math" panose="02040503050406030204" pitchFamily="18" charset="0"/>
                           <a:cs typeface="+mn-cs"/>
                         </a:rPr>
-                        <ns5:t>𝑧𝑒𝑟𝑜</ns5:t>
-                      </ns5:r>
-                      <ns5:r>
+                        <m:t>𝑧𝑒𝑟𝑜</m:t>
+                      </m:r>
+                      <m:r>
                         <a:rPr kumimoji="0" lang="en-US" sz="1800" b="0" i="1" u="none" strike="noStrike" kern="1200" cap="none" spc="0" normalizeH="0" baseline="0" noProof="0" smtClean="0">
                           <a:ln>
                             <a:noFill/>
@@ -8140,11 +7839,11 @@
                           <a:ea typeface="Cambria Math" panose="02040503050406030204" pitchFamily="18" charset="0"/>
                           <a:cs typeface="+mn-cs"/>
                         </a:rPr>
-                        <ns5:t>.</ns5:t>
-                      </ns5:r>
-                    </ns5:oMath>
-                  </ns5:oMathPara>
-                </ns4:m>
+                        <m:t>.</m:t>
+                      </m:r>
+                    </m:oMath>
+                  </m:oMathPara>
+                </a14:m>
                 <a:endParaRPr kumimoji="0" lang="en-US" sz="1800" b="0" i="1" u="none" strike="noStrike" kern="1200" cap="none" spc="0" normalizeH="0" baseline="0" noProof="0" dirty="0">
                   <a:ln>
                     <a:noFill/>
@@ -8178,13 +7877,13 @@
                   <a:tabLst/>
                   <a:defRPr/>
                 </a:pPr>
-                <ns4:m>
-                  <ns5:oMathPara>
-                    <ns5:oMathParaPr>
-                      <ns5:jc ns5:val="centerGroup"/>
-                    </ns5:oMathParaPr>
-                    <ns5:oMath>
-                      <ns5:r>
+                <a14:m>
+                  <m:oMathPara>
+                    <m:oMathParaPr>
+                      <m:jc m:val="centerGroup"/>
+                    </m:oMathParaPr>
+                    <m:oMath>
+                      <m:r>
                         <a:rPr kumimoji="0" lang="en-US" sz="1800" b="0" i="1" u="none" strike="noStrike" kern="1200" cap="none" spc="0" normalizeH="0" baseline="0" noProof="0" smtClean="0">
                           <a:ln>
                             <a:noFill/>
@@ -8199,11 +7898,11 @@
                           <a:ea typeface="Cambria Math" panose="02040503050406030204" pitchFamily="18" charset="0"/>
                           <a:cs typeface="+mn-cs"/>
                         </a:rPr>
-                        <ns5:t> </ns5:t>
-                      </ns5:r>
-                    </ns5:oMath>
-                  </ns5:oMathPara>
-                </ns4:m>
+                        <m:t> </m:t>
+                      </m:r>
+                    </m:oMath>
+                  </m:oMathPara>
+                </a14:m>
                 <a:endParaRPr kumimoji="0" lang="en-US" sz="1800" b="0" i="0" u="none" strike="noStrike" kern="1200" cap="none" spc="0" normalizeH="0" baseline="0" noProof="0" dirty="0">
                   <a:ln>
                     <a:noFill/>
@@ -8222,50 +7921,7 @@
             </p:txBody>
           </p:sp>
         </ns2:Choice>
-        <ns2:Fallback>
-          <p:sp>
-            <p:nvSpPr>
-              <p:cNvPr id="22" name="TextBox 21">
-                <a:extLst>
-                  <a:ext uri="{FF2B5EF4-FFF2-40B4-BE49-F238E27FC236}">
-                    <a16:creationId id="{2F270859-FECE-2645-A10D-F6319FAE5B09}"/>
-                  </a:ext>
-                </a:extLst>
-              </p:cNvPr>
-              <p:cNvSpPr txBox="1">
-                <a:spLocks noRot="1" noChangeAspect="1" noMove="1" noResize="1" noEditPoints="1" noAdjustHandles="1" noChangeArrowheads="1" noChangeShapeType="1" noTextEdit="1"/>
-              </p:cNvSpPr>
-              <p:nvPr/>
-            </p:nvSpPr>
-            <p:spPr>
-              <a:xfrm>
-                <a:off x="2088245" y="5135368"/>
-                <a:ext cx="8173712" cy="1477328"/>
-              </a:xfrm>
-              <a:prstGeom prst="rect">
-                <a:avLst/>
-              </a:prstGeom>
-              <a:blipFill>
-                <a:blip r:embed="rId10"/>
-                <a:stretch>
-                  <a:fillRect b="-3419"/>
-                </a:stretch>
-              </a:blipFill>
-            </p:spPr>
-            <p:txBody>
-              <a:bodyPr/>
-              <a:lstStyle/>
-              <a:p>
-                <a:r>
-                  <a:rPr lang="en-US">
-                    <a:noFill/>
-                  </a:rPr>
-                  <a:t> </a:t>
-                </a:r>
-              </a:p>
-            </p:txBody>
-          </p:sp>
-        </ns2:Fallback>
+        <ns2:Fallback/>
       </ns2:AlternateContent>
       <p:sp>
         <p:nvSpPr>
@@ -8585,10 +8241,338 @@
           </a:p>
         </p:txBody>
       </p:sp>
+      <p:sp>
+        <p:nvSpPr>
+          <p:cNvPr id="23" name="TextBox 22"/>
+          <p:cNvSpPr txBox="1"/>
+          <p:nvPr/>
+        </p:nvSpPr>
+        <p:spPr>
+          <a:xfrm>
+            <a:off x="2705240" y="245304"/>
+            <a:ext cx="6591869" cy="369332"/>
+          </a:xfrm>
+          <a:prstGeom prst="rect">
+            <a:avLst/>
+          </a:prstGeom>
+          <a:solidFill>
+            <a:srgbClr val="7030A0"/>
+          </a:solidFill>
+          <a:ln>
+            <a:noFill/>
+          </a:ln>
+        </p:spPr>
+        <p:txBody>
+          <a:bodyPr wrap="none" lIns="0" rIns="0" tIns="0" bIns="0"/>
+          <a:lstStyle/>
+          <a:p>
+            <a:pPr algn="ctr"/>
+            <a:r>
+              <a:rPr sz="1700" b="1" i="1">
+                <a:solidFill>
+                  <a:srgbClr val="FFFFFF"/>
+                </a:solidFill>
+                <a:latin typeface="Cambria"/>
+              </a:rPr>
+              <a:t>Standard matter particle assembly at rest in the aether</a:t>
+            </a:r>
+          </a:p>
+        </p:txBody>
+      </p:sp>
+      <p:sp>
+        <p:nvSpPr>
+          <p:cNvPr id="24" name="TextBox 23"/>
+          <p:cNvSpPr txBox="1"/>
+          <p:nvPr/>
+        </p:nvSpPr>
+        <p:spPr>
+          <a:xfrm>
+            <a:off x="4435747" y="934682"/>
+            <a:ext cx="3478709" cy="369332"/>
+          </a:xfrm>
+          <a:prstGeom prst="rect">
+            <a:avLst/>
+          </a:prstGeom>
+          <a:noFill/>
+          <a:ln>
+            <a:noFill/>
+          </a:ln>
+        </p:spPr>
+        <p:txBody>
+          <a:bodyPr wrap="none" lIns="0" rIns="0" tIns="0" bIns="0"/>
+          <a:lstStyle/>
+          <a:p>
+            <a:pPr algn="ctr"/>
+            <a:r>
+              <a:rPr sz="1800" b="0" i="1">
+                <a:solidFill>
+                  <a:srgbClr val="FFFFFF"/>
+                </a:solidFill>
+                <a:latin typeface="Cambria"/>
+              </a:rPr>
+              <a:t>Einstein : Energy = Mass * c²</a:t>
+            </a:r>
+          </a:p>
+        </p:txBody>
+      </p:sp>
+      <p:sp>
+        <p:nvSpPr>
+          <p:cNvPr id="25" name="TextBox 24"/>
+          <p:cNvSpPr txBox="1"/>
+          <p:nvPr/>
+        </p:nvSpPr>
+        <p:spPr>
+          <a:xfrm>
+            <a:off x="4058368" y="1651873"/>
+            <a:ext cx="4233467" cy="369332"/>
+          </a:xfrm>
+          <a:prstGeom prst="rect">
+            <a:avLst/>
+          </a:prstGeom>
+          <a:noFill/>
+          <a:ln>
+            <a:noFill/>
+          </a:ln>
+        </p:spPr>
+        <p:txBody>
+          <a:bodyPr wrap="none" lIns="0" rIns="0" tIns="0" bIns="0"/>
+          <a:lstStyle/>
+          <a:p>
+            <a:pPr algn="ctr"/>
+            <a:r>
+              <a:rPr sz="1800" b="0" i="1">
+                <a:solidFill>
+                  <a:srgbClr val="FFFFFF"/>
+                </a:solidFill>
+                <a:latin typeface="Cambria"/>
+              </a:rPr>
+              <a:t>Nature : Energy(apparent) = Mass * c²</a:t>
+            </a:r>
+          </a:p>
+        </p:txBody>
+      </p:sp>
+      <p:sp>
+        <p:nvSpPr>
+          <p:cNvPr id="26" name="TextBox 25"/>
+          <p:cNvSpPr txBox="1"/>
+          <p:nvPr/>
+        </p:nvSpPr>
+        <p:spPr>
+          <a:xfrm>
+            <a:off x="2693154" y="2369064"/>
+            <a:ext cx="6963894" cy="369332"/>
+          </a:xfrm>
+          <a:prstGeom prst="rect">
+            <a:avLst/>
+          </a:prstGeom>
+          <a:noFill/>
+          <a:ln>
+            <a:noFill/>
+          </a:ln>
+        </p:spPr>
+        <p:txBody>
+          <a:bodyPr wrap="none" lIns="0" rIns="0" tIns="0" bIns="0"/>
+          <a:lstStyle/>
+          <a:p>
+            <a:pPr algn="ctr"/>
+            <a:r>
+              <a:rPr sz="1800" b="0" i="1">
+                <a:solidFill>
+                  <a:srgbClr val="FFFFFF"/>
+                </a:solidFill>
+                <a:latin typeface="Cambria"/>
+              </a:rPr>
+              <a:t>Energy(total) = Energy(apparent) + Energy(shielded) via superposition</a:t>
+            </a:r>
+          </a:p>
+        </p:txBody>
+      </p:sp>
+      <p:sp>
+        <p:nvSpPr>
+          <p:cNvPr id="27" name="TextBox 26"/>
+          <p:cNvSpPr txBox="1"/>
+          <p:nvPr/>
+        </p:nvSpPr>
+        <p:spPr>
+          <a:xfrm>
+            <a:off x="1179767" y="3086255"/>
+            <a:ext cx="9990668" cy="369332"/>
+          </a:xfrm>
+          <a:prstGeom prst="rect">
+            <a:avLst/>
+          </a:prstGeom>
+          <a:solidFill>
+            <a:srgbClr val="7030A0"/>
+          </a:solidFill>
+          <a:ln>
+            <a:noFill/>
+          </a:ln>
+        </p:spPr>
+        <p:txBody>
+          <a:bodyPr wrap="none" lIns="0" rIns="0" tIns="0" bIns="0"/>
+          <a:lstStyle/>
+          <a:p>
+            <a:pPr algn="ctr"/>
+            <a:r>
+              <a:rPr sz="1700" b="1" i="1">
+                <a:solidFill>
+                  <a:srgbClr val="FFFFFF"/>
+                </a:solidFill>
+                <a:latin typeface="Cambria"/>
+              </a:rPr>
+              <a:t>Architrino isolated in a Euclidean void of space and time (velocity not defined)</a:t>
+            </a:r>
+          </a:p>
+        </p:txBody>
+      </p:sp>
+      <p:sp>
+        <p:nvSpPr>
+          <p:cNvPr id="28" name="TextBox 27"/>
+          <p:cNvSpPr txBox="1"/>
+          <p:nvPr/>
+        </p:nvSpPr>
+        <p:spPr>
+          <a:xfrm>
+            <a:off x="1485772" y="3803446"/>
+            <a:ext cx="9030806" cy="369332"/>
+          </a:xfrm>
+          <a:prstGeom prst="rect">
+            <a:avLst/>
+          </a:prstGeom>
+          <a:noFill/>
+          <a:ln>
+            <a:noFill/>
+          </a:ln>
+        </p:spPr>
+        <p:txBody>
+          <a:bodyPr wrap="none" lIns="0" rIns="0" tIns="0" bIns="0"/>
+          <a:lstStyle/>
+          <a:p>
+            <a:pPr algn="ctr"/>
+            <a:r>
+              <a:rPr sz="1650" b="0" i="1">
+                <a:solidFill>
+                  <a:srgbClr val="FFFFFF"/>
+                </a:solidFill>
+                <a:latin typeface="Cambria"/>
+              </a:rPr>
+              <a:t>Let @ represent the universal constant speed of potential emissions.</a:t>
+            </a:r>
+          </a:p>
+        </p:txBody>
+      </p:sp>
+      <p:sp>
+        <p:nvSpPr>
+          <p:cNvPr id="29" name="TextBox 28"/>
+          <p:cNvSpPr txBox="1"/>
+          <p:nvPr/>
+        </p:nvSpPr>
+        <p:spPr>
+          <a:xfrm>
+            <a:off x="3902331" y="4520636"/>
+            <a:ext cx="4545540" cy="369332"/>
+          </a:xfrm>
+          <a:prstGeom prst="rect">
+            <a:avLst/>
+          </a:prstGeom>
+          <a:noFill/>
+          <a:ln>
+            <a:noFill/>
+          </a:ln>
+        </p:spPr>
+        <p:txBody>
+          <a:bodyPr wrap="none" lIns="0" rIns="0" tIns="0" bIns="0"/>
+          <a:lstStyle/>
+          <a:p>
+            <a:pPr algn="ctr"/>
+            <a:r>
+              <a:rPr sz="1800" b="0" i="1">
+                <a:solidFill>
+                  <a:srgbClr val="FFFFFF"/>
+                </a:solidFill>
+                <a:latin typeface="Cambria"/>
+              </a:rPr>
+              <a:t>Energy(total) = Energy(apparent) = q * @²</a:t>
+            </a:r>
+          </a:p>
+        </p:txBody>
+      </p:sp>
+      <p:sp>
+        <p:nvSpPr>
+          <p:cNvPr id="30" name="TextBox 29"/>
+          <p:cNvSpPr txBox="1"/>
+          <p:nvPr/>
+        </p:nvSpPr>
+        <p:spPr>
+          <a:xfrm>
+            <a:off x="2088245" y="5135368"/>
+            <a:ext cx="8173712" cy="1477328"/>
+          </a:xfrm>
+          <a:prstGeom prst="rect">
+            <a:avLst/>
+          </a:prstGeom>
+          <a:noFill/>
+          <a:ln>
+            <a:noFill/>
+          </a:ln>
+        </p:spPr>
+        <p:txBody>
+          <a:bodyPr wrap="none" lIns="0" rIns="0" tIns="0" bIns="0"/>
+          <a:lstStyle/>
+          <a:p>
+            <a:pPr algn="ctr"/>
+            <a:r>
+              <a:rPr sz="1800" b="1" i="1">
+                <a:solidFill>
+                  <a:srgbClr val="7030A0"/>
+                </a:solidFill>
+                <a:latin typeface="Cambria"/>
+              </a:rPr>
+              <a:t>Duality</a:t>
+            </a:r>
+          </a:p>
+          <a:p>
+            <a:pPr algn="ctr"/>
+            <a:r>
+              <a:rPr sz="1600" b="0" i="1">
+                <a:solidFill>
+                  <a:srgbClr val="FFFFFF"/>
+                </a:solidFill>
+                <a:latin typeface="Cambria"/>
+              </a:rPr>
+              <a:t>Architrino causal wakes travel radially from emission at speed @.</a:t>
+            </a:r>
+          </a:p>
+          <a:p>
+            <a:pPr algn="ctr"/>
+            <a:r>
+              <a:rPr sz="1600" b="0" i="1">
+                <a:solidFill>
+                  <a:srgbClr val="FFFFFF"/>
+                </a:solidFill>
+                <a:latin typeface="Cambria"/>
+              </a:rPr>
+              <a:t>Photon structures travel at c, the local speed of light through the aether.</a:t>
+            </a:r>
+          </a:p>
+          <a:p>
+            <a:pPr algn="ctr"/>
+            <a:r>
+              <a:rPr sz="1600" b="0" i="1">
+                <a:solidFill>
+                  <a:srgbClr val="FFFFFF"/>
+                </a:solidFill>
+                <a:latin typeface="Cambria"/>
+              </a:rPr>
+              <a:t>Local c approaches @ as Energy(apparent) of the aether approaches zero.</a:t>
+            </a:r>
+          </a:p>
+        </p:txBody>
+      </p:sp>
     </p:spTree>
     <p:extLst>
       <p:ext uri="{BB962C8B-B14F-4D97-AF65-F5344CB8AC3E}">
-        <ns7:creationId val="3268287473"/>
+        <ns6:creationId val="3268287473"/>
       </p:ext>
     </p:extLst>
   </p:cSld>

</xml_diff>